<commit_message>
Deck v4: remove filler, split 30-60-90 into three slides
Co-Authored-By: Claude Opus 5.5 <noreply@anthropic.com>
Claude-Session: https://claude.ai/code/session_01WRoyQ7axMmZ4oLT5ox31wx
</commit_message>
<xml_diff>
--- a/doodle-panel/Doodle_Labs_Europe_Panel_FINAL_v4.pptx
+++ b/doodle-panel/Doodle_Labs_Europe_Panel_FINAL_v4.pptx
@@ -17,9 +17,11 @@
     <p:sldId id="265" r:id="rId11"/>
     <p:sldId id="266" r:id="rId12"/>
     <p:sldId id="267" r:id="rId13"/>
+    <p:sldId id="268" r:id="rId14"/>
+    <p:sldId id="269" r:id="rId15"/>
   </p:sldIdLst>
   <p:notesMasterIdLst>
-    <p:notesMasterId r:id="rId14"/>
+    <p:notesMasterId r:id="rId16"/>
   </p:notesMasterIdLst>
   <p:sldSz cx="9144000" cy="5143500"/>
   <p:notesSz cx="5143500" cy="9144000"/>
@@ -945,12 +947,11 @@
           <a:p>
             <a:r>
               <a:rPr lang="en-US" dirty="0"/>
-              <a:t>~60 s. One slide, three gates.
-Existing business: secure the base first — every current account gets a meeting and one question: what are you designing next? New business runs in parallel from week two.
-4–6 evaluations "sized to your SE capacity, which I'd ask you for rather than invent" (you're hiring a Sales Engineer in Germany — ask how capacity is shared until then).
-Design-in clock (my assumption, to calibrate with David): decision ~month 9, certification behind it, first production PO ~month 24. That's why day 90 is about decisions, not revenue.
-Forecast = design-ins × platform volume × attach rate × your price, each input tagged known / assumed.
-Year-one number: "With your installed base and price book I'd commit to a number in week four."</a:t>
+              <a:t>~40 s. Existing and new run in parallel from week two — the base is secured first, not instead.
+The one question for every current customer: "what are you designing next?" — that's where expansion and the next design-in come from.
+Ownership: multi-site OEMs and cross-border accounts get a written rule before the first conflict, not after.
+SE capacity: "I'd ask you for the number rather than invent one." You're hiring a Sales Engineer in Germany — ask how capacity is shared until then.
+CRM: Doodle uses HubSpot (per the SE job post); I've run pipeline in Pipedrive.</a:t>
             </a:r>
             <a:endParaRPr lang="en-US" dirty="0"/>
           </a:p>
@@ -1038,11 +1039,10 @@
           <a:p>
             <a:r>
               <a:rPr lang="en-US" dirty="0"/>
-              <a:t>~30 s, then stop and listen.
-Growth → Amol. Ownership → Andy. Success → Andy.
-Have your own answer if they turn it back: "My guess from outside is expansion inside platforms you're already on, plus a few new logos where production is ramping — but you see the baseline, I don't."
-Southern Europe, if asked: "I'd be very comfortable owning Southern Europe and building it properly — France already has contracted volume. What I'd like to agree early is the rule for strategic accounts."
-Follow-ups to keep: SE capacity in Europe; the typical evaluation-to-LRIP path in the US (to David); existing European customers and evaluations this role would inherit.</a:t>
+              <a:t>~40 s. An eval kit shipped is not progress; an evaluation with agreed criteria, owner and decision date is.
+Why 4–6: one Sales Engineer can't run more strategic evaluations well; at the cap, the newest account waits.
+Second band: Dual Radio (Sep-2026) gives existing users a concrete reason to talk — test it as a hypothesis, not a pitch.
+Partners: private-label first (Solace, Broadcast Solutions); exclusivity only if earned; export check before the first call.</a:t>
             </a:r>
             <a:endParaRPr lang="en-US" dirty="0"/>
           </a:p>
@@ -1130,9 +1130,11 @@
           <a:p>
             <a:r>
               <a:rPr lang="en-US" dirty="0"/>
-              <a:t>Only if asked "where do these numbers come from?" or "how did you do it in an hour?".
-One-hour answer (same as September, more precise): "The first pass took about an hour — pulling European companies and matching platforms against your catalogue. That's discovery, not verification. Verifying bands, contacts and who names which radio took weeks, and I rebuilt the scoring once when I found it double-counting."
-Mention ≠ customer. No published radio ≠ open socket. Band overlap ≠ validated integration.</a:t>
+              <a:t>~45 s. Revenue in the first 90 days comes from existing customers; new logos produce decisions, not invoices.
+Forecast = design-ins × platform volume × radios per platform × your price, each input tagged known or assumed, weighted by your stage benchmarks — not mine.
+Design-in clock (my assumption, to calibrate with David): decision ~month 9, certification behind it, first production PO ~month 24.
+Year-one number: "With your installed base and price book I'd commit to a number in week four."
+Closing line for this section: "Thirty days buy information, sixty buy proof, ninety buy commitment."</a:t>
             </a:r>
             <a:endParaRPr lang="en-US" dirty="0"/>
           </a:p>
@@ -1156,6 +1158,188 @@
             <a:fld id="{F7021451-1387-4CA6-816F-3879F97B5CBC}" type="slidenum">
               <a:rPr lang="en-US"/>
               <a:t>12</a:t>
+            </a:fld>
+            <a:endParaRPr lang="en-US"/>
+          </a:p>
+        </p:txBody>
+      </p:sp>
+    </p:spTree>
+    <p:extLst>
+      <p:ext uri="{BB962C8B-B14F-4D97-AF65-F5344CB8AC3E}">
+        <p14:creationId xmlns:p14="http://schemas.microsoft.com/office/powerpoint/2010/main" val="1024086991"/>
+      </p:ext>
+    </p:extLst>
+  </p:cSld>
+  <p:clrMapOvr>
+    <a:masterClrMapping/>
+  </p:clrMapOvr>
+</p:notes>
+</file>
+
+<file path=ppt/notesSlides/notesSlide13.xml><?xml version="1.0" encoding="utf-8"?>
+<p:notes xmlns:a="http://schemas.openxmlformats.org/drawingml/2006/main" xmlns:r="http://schemas.openxmlformats.org/officeDocument/2006/relationships" xmlns:p="http://schemas.openxmlformats.org/presentationml/2006/main">
+  <p:cSld>
+    <p:spTree>
+      <p:nvGrpSpPr>
+        <p:cNvPr id="1" name=""/>
+        <p:cNvGrpSpPr/>
+        <p:nvPr/>
+      </p:nvGrpSpPr>
+      <p:grpSpPr>
+        <a:xfrm>
+          <a:off x="0" y="0"/>
+          <a:ext cx="0" cy="0"/>
+          <a:chOff x="0" y="0"/>
+          <a:chExt cx="0" cy="0"/>
+        </a:xfrm>
+      </p:grpSpPr>
+      <p:sp>
+        <p:nvSpPr>
+          <p:cNvPr id="2" name="Slide Image Placeholder 1"/>
+          <p:cNvSpPr>
+            <a:spLocks noGrp="1" noRot="1" noChangeAspect="1"/>
+          </p:cNvSpPr>
+          <p:nvPr>
+            <p:ph type="sldImg"/>
+          </p:nvPr>
+        </p:nvSpPr>
+        <p:spPr/>
+      </p:sp>
+      <p:sp>
+        <p:nvSpPr>
+          <p:cNvPr id="3" name="Notes Placeholder 2"/>
+          <p:cNvSpPr>
+            <a:spLocks noGrp="1"/>
+          </p:cNvSpPr>
+          <p:nvPr>
+            <p:ph type="body" idx="1"/>
+          </p:nvPr>
+        </p:nvSpPr>
+        <p:spPr/>
+        <p:txBody>
+          <a:bodyPr/>
+          <a:lstStyle/>
+          <a:p>
+            <a:r>
+              <a:rPr lang="en-US" dirty="0"/>
+              <a:t>~30 s, then stop and listen.
+Growth → Amol. Ownership → Andy. Success → Andy.
+Have your own answer if they turn it back: "My guess from outside is expansion inside platforms you're already on, plus a few new logos where production is ramping — but you see the baseline, I don't."
+Southern Europe, if asked: "I'd be very comfortable owning Southern Europe and building it properly — France already has contracted volume. What I'd like to agree early is the rule for strategic accounts."
+Follow-ups to keep: SE capacity in Europe; the typical evaluation-to-LRIP path in the US (to David); existing European customers and evaluations this role would inherit.</a:t>
+            </a:r>
+            <a:endParaRPr lang="en-US" dirty="0"/>
+          </a:p>
+        </p:txBody>
+      </p:sp>
+      <p:sp>
+        <p:nvSpPr>
+          <p:cNvPr id="4" name="Slide Number Placeholder 3"/>
+          <p:cNvSpPr>
+            <a:spLocks noGrp="1"/>
+          </p:cNvSpPr>
+          <p:nvPr>
+            <p:ph type="sldNum" sz="quarter" idx="10"/>
+          </p:nvPr>
+        </p:nvSpPr>
+        <p:spPr/>
+        <p:txBody>
+          <a:bodyPr/>
+          <a:lstStyle/>
+          <a:p>
+            <a:fld id="{F7021451-1387-4CA6-816F-3879F97B5CBC}" type="slidenum">
+              <a:rPr lang="en-US"/>
+              <a:t>13</a:t>
+            </a:fld>
+            <a:endParaRPr lang="en-US"/>
+          </a:p>
+        </p:txBody>
+      </p:sp>
+    </p:spTree>
+    <p:extLst>
+      <p:ext uri="{BB962C8B-B14F-4D97-AF65-F5344CB8AC3E}">
+        <p14:creationId xmlns:p14="http://schemas.microsoft.com/office/powerpoint/2010/main" val="1024086991"/>
+      </p:ext>
+    </p:extLst>
+  </p:cSld>
+  <p:clrMapOvr>
+    <a:masterClrMapping/>
+  </p:clrMapOvr>
+</p:notes>
+</file>
+
+<file path=ppt/notesSlides/notesSlide14.xml><?xml version="1.0" encoding="utf-8"?>
+<p:notes xmlns:a="http://schemas.openxmlformats.org/drawingml/2006/main" xmlns:r="http://schemas.openxmlformats.org/officeDocument/2006/relationships" xmlns:p="http://schemas.openxmlformats.org/presentationml/2006/main">
+  <p:cSld>
+    <p:spTree>
+      <p:nvGrpSpPr>
+        <p:cNvPr id="1" name=""/>
+        <p:cNvGrpSpPr/>
+        <p:nvPr/>
+      </p:nvGrpSpPr>
+      <p:grpSpPr>
+        <a:xfrm>
+          <a:off x="0" y="0"/>
+          <a:ext cx="0" cy="0"/>
+          <a:chOff x="0" y="0"/>
+          <a:chExt cx="0" cy="0"/>
+        </a:xfrm>
+      </p:grpSpPr>
+      <p:sp>
+        <p:nvSpPr>
+          <p:cNvPr id="2" name="Slide Image Placeholder 1"/>
+          <p:cNvSpPr>
+            <a:spLocks noGrp="1" noRot="1" noChangeAspect="1"/>
+          </p:cNvSpPr>
+          <p:nvPr>
+            <p:ph type="sldImg"/>
+          </p:nvPr>
+        </p:nvSpPr>
+        <p:spPr/>
+      </p:sp>
+      <p:sp>
+        <p:nvSpPr>
+          <p:cNvPr id="3" name="Notes Placeholder 2"/>
+          <p:cNvSpPr>
+            <a:spLocks noGrp="1"/>
+          </p:cNvSpPr>
+          <p:nvPr>
+            <p:ph type="body" idx="1"/>
+          </p:nvPr>
+        </p:nvSpPr>
+        <p:spPr/>
+        <p:txBody>
+          <a:bodyPr/>
+          <a:lstStyle/>
+          <a:p>
+            <a:r>
+              <a:rPr lang="en-US" dirty="0"/>
+              <a:t>Only if asked "where do these numbers come from?" or "how did you do it in an hour?".
+One-hour answer (same as September, more precise): "The first pass took about an hour — pulling European companies and matching platforms against your catalogue. That's discovery, not verification. Verifying bands, contacts and who names which radio took weeks, and I rebuilt the scoring once when I found it double-counting."
+Mention ≠ customer. No published radio ≠ open socket. Band overlap ≠ validated integration.</a:t>
+            </a:r>
+            <a:endParaRPr lang="en-US" dirty="0"/>
+          </a:p>
+        </p:txBody>
+      </p:sp>
+      <p:sp>
+        <p:nvSpPr>
+          <p:cNvPr id="4" name="Slide Number Placeholder 3"/>
+          <p:cNvSpPr>
+            <a:spLocks noGrp="1"/>
+          </p:cNvSpPr>
+          <p:nvPr>
+            <p:ph type="sldNum" sz="quarter" idx="10"/>
+          </p:nvPr>
+        </p:nvSpPr>
+        <p:spPr/>
+        <p:txBody>
+          <a:bodyPr/>
+          <a:lstStyle/>
+          <a:p>
+            <a:fld id="{F7021451-1387-4CA6-816F-3879F97B5CBC}" type="slidenum">
+              <a:rPr lang="en-US"/>
+              <a:t>14</a:t>
             </a:fld>
             <a:endParaRPr lang="en-US"/>
           </a:p>
@@ -2690,45 +2874,6 @@
           </a:p>
         </p:txBody>
       </p:sp>
-      <p:sp>
-        <p:nvSpPr>
-          <p:cNvPr id="13" name="Text 11"/>
-          <p:cNvSpPr txBox="1"/>
-          <p:nvPr/>
-        </p:nvSpPr>
-        <p:spPr>
-          <a:xfrm>
-            <a:off x="640080" y="4590288"/>
-            <a:ext cx="7863840" cy="256032"/>
-          </a:xfrm>
-          <a:prstGeom prst="rect">
-            <a:avLst/>
-          </a:prstGeom>
-          <a:noFill/>
-          <a:ln/>
-        </p:spPr>
-        <p:txBody>
-          <a:bodyPr wrap="square" lIns="0" tIns="0" rIns="0" bIns="0" rtlCol="0" anchor="ctr"/>
-          <a:lstStyle/>
-          <a:p>
-            <a:pPr indent="0" marL="0">
-              <a:buNone/>
-            </a:pPr>
-            <a:r>
-              <a:rPr lang="en-US" sz="950" dirty="0">
-                <a:solidFill>
-                  <a:srgbClr val="8E98A3"/>
-                </a:solidFill>
-                <a:latin typeface="Segoe UI" pitchFamily="34" charset="0"/>
-                <a:ea typeface="Segoe UI" pitchFamily="34" charset="-122"/>
-                <a:cs typeface="Segoe UI" pitchFamily="34" charset="-120"/>
-              </a:rPr>
-              <a:t>Outside-in view from public sources — a hypothesis to test against your CRM, not your forecast.</a:t>
-            </a:r>
-            <a:endParaRPr lang="en-US" sz="950" dirty="0"/>
-          </a:p>
-        </p:txBody>
-      </p:sp>
     </p:spTree>
   </p:cSld>
   <p:clrMapOvr>
@@ -2794,7 +2939,7 @@
                 <a:ea typeface="Consolas" pitchFamily="34" charset="-122"/>
                 <a:cs typeface="Consolas" pitchFamily="34" charset="-120"/>
               </a:rPr>
-              <a:t>4 · 30-60-90 · EXISTING + NEW BUSINESS</a:t>
+              <a:t>4 · 30-60-90 · DAYS 1–30</a:t>
             </a:r>
             <a:endParaRPr lang="en-US" sz="950" dirty="0"/>
           </a:p>
@@ -2833,7 +2978,7 @@
                 <a:ea typeface="Segoe UI" pitchFamily="34" charset="-122"/>
                 <a:cs typeface="Segoe UI" pitchFamily="34" charset="-120"/>
               </a:rPr>
-              <a:t>30 days information · 60 proof · 90 commitment</a:t>
+              <a:t>Days 1–30: know what we have first</a:t>
             </a:r>
             <a:endParaRPr lang="en-US" sz="2200" dirty="0"/>
           </a:p>
@@ -2841,14 +2986,39 @@
       </p:sp>
       <p:sp>
         <p:nvSpPr>
-          <p:cNvPr id="4" name="Text 2"/>
-          <p:cNvSpPr txBox="1"/>
-          <p:nvPr/>
-        </p:nvSpPr>
-        <p:spPr>
-          <a:xfrm>
-            <a:off x="640080" y="4590288"/>
-            <a:ext cx="7863840" cy="256032"/>
+          <p:cNvPr id="4" name="Shape 2"/>
+          <p:cNvSpPr/>
+          <p:nvPr/>
+        </p:nvSpPr>
+        <p:spPr>
+          <a:xfrm>
+            <a:off x="7223760" y="329184"/>
+            <a:ext cx="329184" cy="329184"/>
+          </a:xfrm>
+          <a:prstGeom prst="ellipse">
+            <a:avLst/>
+          </a:prstGeom>
+          <a:solidFill>
+            <a:srgbClr val="F05A55"/>
+          </a:solidFill>
+          <a:ln w="9525">
+            <a:solidFill>
+              <a:srgbClr val="F05A55"/>
+            </a:solidFill>
+            <a:prstDash val="solid"/>
+          </a:ln>
+        </p:spPr>
+      </p:sp>
+      <p:sp>
+        <p:nvSpPr>
+          <p:cNvPr id="5" name="Text 3"/>
+          <p:cNvSpPr txBox="1"/>
+          <p:nvPr/>
+        </p:nvSpPr>
+        <p:spPr>
+          <a:xfrm>
+            <a:off x="7223760" y="329184"/>
+            <a:ext cx="329184" cy="329184"/>
           </a:xfrm>
           <a:prstGeom prst="rect">
             <a:avLst/>
@@ -2860,36 +3030,36 @@
           <a:bodyPr wrap="square" lIns="0" tIns="0" rIns="0" bIns="0" rtlCol="0" anchor="ctr"/>
           <a:lstStyle/>
           <a:p>
-            <a:pPr indent="0" marL="0">
-              <a:buNone/>
-            </a:pPr>
-            <a:r>
-              <a:rPr lang="en-US" sz="950" dirty="0">
-                <a:solidFill>
-                  <a:srgbClr val="F05A55"/>
-                </a:solidFill>
-                <a:latin typeface="Segoe UI" pitchFamily="34" charset="0"/>
-                <a:ea typeface="Segoe UI" pitchFamily="34" charset="-122"/>
-                <a:cs typeface="Segoe UI" pitchFamily="34" charset="-120"/>
-              </a:rPr>
-              <a:t>I won't promise production wins in 90 days. I'll promise you know exactly where every account stands.</a:t>
-            </a:r>
-            <a:endParaRPr lang="en-US" sz="950" dirty="0"/>
-          </a:p>
-        </p:txBody>
-      </p:sp>
-      <p:sp>
-        <p:nvSpPr>
-          <p:cNvPr id="5" name="Shape 3"/>
+            <a:pPr algn="ctr" indent="0" marL="0">
+              <a:buNone/>
+            </a:pPr>
+            <a:r>
+              <a:rPr lang="en-US" sz="900" b="1" dirty="0">
+                <a:solidFill>
+                  <a:srgbClr val="0B0D10"/>
+                </a:solidFill>
+                <a:latin typeface="Segoe UI" pitchFamily="34" charset="0"/>
+                <a:ea typeface="Segoe UI" pitchFamily="34" charset="-122"/>
+                <a:cs typeface="Segoe UI" pitchFamily="34" charset="-120"/>
+              </a:rPr>
+              <a:t>30</a:t>
+            </a:r>
+            <a:endParaRPr lang="en-US" sz="900" dirty="0"/>
+          </a:p>
+        </p:txBody>
+      </p:sp>
+      <p:sp>
+        <p:nvSpPr>
+          <p:cNvPr id="6" name="Shape 4"/>
           <p:cNvSpPr/>
           <p:nvPr/>
         </p:nvSpPr>
         <p:spPr>
           <a:xfrm>
-            <a:off x="640080" y="1371600"/>
-            <a:ext cx="2468880" cy="3017520"/>
-          </a:xfrm>
-          <a:prstGeom prst="rect">
+            <a:off x="7662672" y="329184"/>
+            <a:ext cx="329184" cy="329184"/>
+          </a:xfrm>
+          <a:prstGeom prst="ellipse">
             <a:avLst/>
           </a:prstGeom>
           <a:solidFill>
@@ -2905,14 +3075,14 @@
       </p:sp>
       <p:sp>
         <p:nvSpPr>
-          <p:cNvPr id="6" name="Text 4"/>
-          <p:cNvSpPr txBox="1"/>
-          <p:nvPr/>
-        </p:nvSpPr>
-        <p:spPr>
-          <a:xfrm>
-            <a:off x="822960" y="1508760"/>
-            <a:ext cx="2148840" cy="274320"/>
+          <p:cNvPr id="7" name="Text 5"/>
+          <p:cNvSpPr txBox="1"/>
+          <p:nvPr/>
+        </p:nvSpPr>
+        <p:spPr>
+          <a:xfrm>
+            <a:off x="7662672" y="329184"/>
+            <a:ext cx="329184" cy="329184"/>
           </a:xfrm>
           <a:prstGeom prst="rect">
             <a:avLst/>
@@ -2924,19 +3094,19 @@
           <a:bodyPr wrap="square" lIns="0" tIns="0" rIns="0" bIns="0" rtlCol="0" anchor="ctr"/>
           <a:lstStyle/>
           <a:p>
-            <a:pPr indent="0" marL="0">
-              <a:buNone/>
-            </a:pPr>
-            <a:r>
-              <a:rPr lang="en-US" sz="900" dirty="0">
-                <a:solidFill>
-                  <a:srgbClr val="F05A55"/>
-                </a:solidFill>
-                <a:latin typeface="Consolas" pitchFamily="34" charset="0"/>
-                <a:ea typeface="Consolas" pitchFamily="34" charset="-122"/>
-                <a:cs typeface="Consolas" pitchFamily="34" charset="-120"/>
-              </a:rPr>
-              <a:t>DAYS 1–30 · INFORMATION</a:t>
+            <a:pPr algn="ctr" indent="0" marL="0">
+              <a:buNone/>
+            </a:pPr>
+            <a:r>
+              <a:rPr lang="en-US" sz="900" b="1" dirty="0">
+                <a:solidFill>
+                  <a:srgbClr val="8E98A3"/>
+                </a:solidFill>
+                <a:latin typeface="Segoe UI" pitchFamily="34" charset="0"/>
+                <a:ea typeface="Segoe UI" pitchFamily="34" charset="-122"/>
+                <a:cs typeface="Segoe UI" pitchFamily="34" charset="-120"/>
+              </a:rPr>
+              <a:t>60</a:t>
             </a:r>
             <a:endParaRPr lang="en-US" sz="900" dirty="0"/>
           </a:p>
@@ -2944,154 +3114,16 @@
       </p:sp>
       <p:sp>
         <p:nvSpPr>
-          <p:cNvPr id="7" name="Text 5"/>
-          <p:cNvSpPr txBox="1"/>
-          <p:nvPr/>
-        </p:nvSpPr>
-        <p:spPr>
-          <a:xfrm>
-            <a:off x="822960" y="1874520"/>
-            <a:ext cx="2148840" cy="1828800"/>
-          </a:xfrm>
-          <a:prstGeom prst="rect">
-            <a:avLst/>
-          </a:prstGeom>
-          <a:noFill/>
-          <a:ln/>
-        </p:spPr>
-        <p:txBody>
-          <a:bodyPr wrap="square" lIns="0" tIns="0" rIns="0" bIns="0" rtlCol="0" anchor="t"/>
-          <a:lstStyle/>
-          <a:p>
-            <a:pPr marL="342900" indent="-342900">
-              <a:spcAft>
-                <a:spcPts val="600"/>
-              </a:spcAft>
-              <a:buSzPct val="100000"/>
-              <a:buChar char="•"/>
-            </a:pPr>
-            <a:r>
-              <a:rPr lang="en-US" sz="1100" dirty="0">
-                <a:solidFill>
-                  <a:srgbClr val="C9CED4"/>
-                </a:solidFill>
-                <a:latin typeface="Segoe UI" pitchFamily="34" charset="0"/>
-                <a:ea typeface="Segoe UI" pitchFamily="34" charset="-122"/>
-                <a:cs typeface="Segoe UI" pitchFamily="34" charset="-120"/>
-              </a:rPr>
-              <a:t>Reconcile my map with your CRM, installed base and account ownership</a:t>
-            </a:r>
-            <a:endParaRPr lang="en-US" sz="1100" dirty="0"/>
-          </a:p>
-          <a:p>
-            <a:pPr marL="342900" indent="-342900">
-              <a:spcAft>
-                <a:spcPts val="600"/>
-              </a:spcAft>
-              <a:buSzPct val="100000"/>
-              <a:buChar char="•"/>
-            </a:pPr>
-            <a:r>
-              <a:rPr lang="en-US" sz="1100" dirty="0">
-                <a:solidFill>
-                  <a:srgbClr val="C9CED4"/>
-                </a:solidFill>
-                <a:latin typeface="Segoe UI" pitchFamily="34" charset="0"/>
-                <a:ea typeface="Segoe UI" pitchFamily="34" charset="-122"/>
-                <a:cs typeface="Segoe UI" pitchFamily="34" charset="-120"/>
-              </a:rPr>
-              <a:t>Meet every existing customer: what are you designing next?</a:t>
-            </a:r>
-            <a:endParaRPr lang="en-US" sz="1100" dirty="0"/>
-          </a:p>
-          <a:p>
-            <a:pPr marL="342900" indent="-342900">
-              <a:spcAft>
-                <a:spcPts val="600"/>
-              </a:spcAft>
-              <a:buSzPct val="100000"/>
-              <a:buChar char="•"/>
-            </a:pPr>
-            <a:r>
-              <a:rPr lang="en-US" sz="1100" dirty="0">
-                <a:solidFill>
-                  <a:srgbClr val="C9CED4"/>
-                </a:solidFill>
-                <a:latin typeface="Segoe UI" pitchFamily="34" charset="0"/>
-                <a:ea typeface="Segoe UI" pitchFamily="34" charset="-122"/>
-                <a:cs typeface="Segoe UI" pitchFamily="34" charset="-120"/>
-              </a:rPr>
-              <a:t>Agree a written qualification standard</a:t>
-            </a:r>
-            <a:endParaRPr lang="en-US" sz="1100" dirty="0"/>
-          </a:p>
-        </p:txBody>
-      </p:sp>
-      <p:sp>
-        <p:nvSpPr>
-          <p:cNvPr id="8" name="Text 6"/>
-          <p:cNvSpPr txBox="1"/>
-          <p:nvPr/>
-        </p:nvSpPr>
-        <p:spPr>
-          <a:xfrm>
-            <a:off x="822960" y="3794760"/>
-            <a:ext cx="2148840" cy="457200"/>
-          </a:xfrm>
-          <a:prstGeom prst="rect">
-            <a:avLst/>
-          </a:prstGeom>
-          <a:noFill/>
-          <a:ln/>
-        </p:spPr>
-        <p:txBody>
-          <a:bodyPr wrap="square" lIns="0" tIns="0" rIns="0" bIns="0" rtlCol="0" anchor="ctr"/>
-          <a:lstStyle/>
-          <a:p>
-            <a:pPr indent="0" marL="0">
-              <a:buNone/>
-            </a:pPr>
-            <a:r>
-              <a:rPr lang="en-US" sz="900" dirty="0">
-                <a:solidFill>
-                  <a:srgbClr val="8E98A3"/>
-                </a:solidFill>
-                <a:latin typeface="Consolas" pitchFamily="34" charset="0"/>
-                <a:ea typeface="Consolas" pitchFamily="34" charset="-122"/>
-                <a:cs typeface="Consolas" pitchFamily="34" charset="-120"/>
-              </a:rPr>
-              <a:t>GATE  </a:t>
-            </a:r>
-            <a:pPr indent="0" marL="0">
-              <a:buNone/>
-            </a:pPr>
-            <a:r>
-              <a:rPr lang="en-US" sz="1100" b="1" dirty="0">
-                <a:solidFill>
-                  <a:srgbClr val="F2F4F6"/>
-                </a:solidFill>
-                <a:latin typeface="Segoe UI" pitchFamily="34" charset="0"/>
-                <a:ea typeface="Segoe UI" pitchFamily="34" charset="-122"/>
-                <a:cs typeface="Segoe UI" pitchFamily="34" charset="-120"/>
-              </a:rPr>
-              <a:t>Agreed baseline</a:t>
-            </a:r>
-            <a:endParaRPr lang="en-US" sz="1100" dirty="0"/>
-          </a:p>
-        </p:txBody>
-      </p:sp>
-      <p:sp>
-        <p:nvSpPr>
-          <p:cNvPr id="9" name="Shape 7"/>
+          <p:cNvPr id="8" name="Shape 6"/>
           <p:cNvSpPr/>
           <p:nvPr/>
         </p:nvSpPr>
         <p:spPr>
           <a:xfrm>
-            <a:off x="3337560" y="1371600"/>
-            <a:ext cx="2468880" cy="3017520"/>
-          </a:xfrm>
-          <a:prstGeom prst="rect">
+            <a:off x="8101584" y="329184"/>
+            <a:ext cx="329184" cy="329184"/>
+          </a:xfrm>
+          <a:prstGeom prst="ellipse">
             <a:avLst/>
           </a:prstGeom>
           <a:solidFill>
@@ -3107,14 +3139,14 @@
       </p:sp>
       <p:sp>
         <p:nvSpPr>
-          <p:cNvPr id="10" name="Text 8"/>
-          <p:cNvSpPr txBox="1"/>
-          <p:nvPr/>
-        </p:nvSpPr>
-        <p:spPr>
-          <a:xfrm>
-            <a:off x="3520440" y="1508760"/>
-            <a:ext cx="2148840" cy="274320"/>
+          <p:cNvPr id="9" name="Text 7"/>
+          <p:cNvSpPr txBox="1"/>
+          <p:nvPr/>
+        </p:nvSpPr>
+        <p:spPr>
+          <a:xfrm>
+            <a:off x="8101584" y="329184"/>
+            <a:ext cx="329184" cy="329184"/>
           </a:xfrm>
           <a:prstGeom prst="rect">
             <a:avLst/>
@@ -3126,19 +3158,19 @@
           <a:bodyPr wrap="square" lIns="0" tIns="0" rIns="0" bIns="0" rtlCol="0" anchor="ctr"/>
           <a:lstStyle/>
           <a:p>
-            <a:pPr indent="0" marL="0">
-              <a:buNone/>
-            </a:pPr>
-            <a:r>
-              <a:rPr lang="en-US" sz="900" dirty="0">
-                <a:solidFill>
-                  <a:srgbClr val="F05A55"/>
-                </a:solidFill>
-                <a:latin typeface="Consolas" pitchFamily="34" charset="0"/>
-                <a:ea typeface="Consolas" pitchFamily="34" charset="-122"/>
-                <a:cs typeface="Consolas" pitchFamily="34" charset="-120"/>
-              </a:rPr>
-              <a:t>DAYS 31–60 · PROOF</a:t>
+            <a:pPr algn="ctr" indent="0" marL="0">
+              <a:buNone/>
+            </a:pPr>
+            <a:r>
+              <a:rPr lang="en-US" sz="900" b="1" dirty="0">
+                <a:solidFill>
+                  <a:srgbClr val="8E98A3"/>
+                </a:solidFill>
+                <a:latin typeface="Segoe UI" pitchFamily="34" charset="0"/>
+                <a:ea typeface="Segoe UI" pitchFamily="34" charset="-122"/>
+                <a:cs typeface="Segoe UI" pitchFamily="34" charset="-120"/>
+              </a:rPr>
+              <a:t>90</a:t>
             </a:r>
             <a:endParaRPr lang="en-US" sz="900" dirty="0"/>
           </a:p>
@@ -3146,152 +3178,14 @@
       </p:sp>
       <p:sp>
         <p:nvSpPr>
-          <p:cNvPr id="11" name="Text 9"/>
-          <p:cNvSpPr txBox="1"/>
-          <p:nvPr/>
-        </p:nvSpPr>
-        <p:spPr>
-          <a:xfrm>
-            <a:off x="3520440" y="1874520"/>
-            <a:ext cx="2148840" cy="1828800"/>
-          </a:xfrm>
-          <a:prstGeom prst="rect">
-            <a:avLst/>
-          </a:prstGeom>
-          <a:noFill/>
-          <a:ln/>
-        </p:spPr>
-        <p:txBody>
-          <a:bodyPr wrap="square" lIns="0" tIns="0" rIns="0" bIns="0" rtlCol="0" anchor="t"/>
-          <a:lstStyle/>
-          <a:p>
-            <a:pPr marL="342900" indent="-342900">
-              <a:spcAft>
-                <a:spcPts val="600"/>
-              </a:spcAft>
-              <a:buSzPct val="100000"/>
-              <a:buChar char="•"/>
-            </a:pPr>
-            <a:r>
-              <a:rPr lang="en-US" sz="1100" dirty="0">
-                <a:solidFill>
-                  <a:srgbClr val="C9CED4"/>
-                </a:solidFill>
-                <a:latin typeface="Segoe UI" pitchFamily="34" charset="0"/>
-                <a:ea typeface="Segoe UI" pitchFamily="34" charset="-122"/>
-                <a:cs typeface="Segoe UI" pitchFamily="34" charset="-120"/>
-              </a:rPr>
-              <a:t>Run 4–6 customer evaluations, sized to SE capacity</a:t>
-            </a:r>
-            <a:endParaRPr lang="en-US" sz="1100" dirty="0"/>
-          </a:p>
-          <a:p>
-            <a:pPr marL="342900" indent="-342900">
-              <a:spcAft>
-                <a:spcPts val="600"/>
-              </a:spcAft>
-              <a:buSzPct val="100000"/>
-              <a:buChar char="•"/>
-            </a:pPr>
-            <a:r>
-              <a:rPr lang="en-US" sz="1100" dirty="0">
-                <a:solidFill>
-                  <a:srgbClr val="C9CED4"/>
-                </a:solidFill>
-                <a:latin typeface="Segoe UI" pitchFamily="34" charset="0"/>
-                <a:ea typeface="Segoe UI" pitchFamily="34" charset="-122"/>
-                <a:cs typeface="Segoe UI" pitchFamily="34" charset="-120"/>
-              </a:rPr>
-              <a:t>Open 1–2 partners in bounded pilots</a:t>
-            </a:r>
-            <a:endParaRPr lang="en-US" sz="1100" dirty="0"/>
-          </a:p>
-          <a:p>
-            <a:pPr marL="342900" indent="-342900">
-              <a:spcAft>
-                <a:spcPts val="600"/>
-              </a:spcAft>
-              <a:buSzPct val="100000"/>
-              <a:buChar char="•"/>
-            </a:pPr>
-            <a:r>
-              <a:rPr lang="en-US" sz="1100" dirty="0">
-                <a:solidFill>
-                  <a:srgbClr val="C9CED4"/>
-                </a:solidFill>
-                <a:latin typeface="Segoe UI" pitchFamily="34" charset="0"/>
-                <a:ea typeface="Segoe UI" pitchFamily="34" charset="-122"/>
-                <a:cs typeface="Segoe UI" pitchFamily="34" charset="-120"/>
-              </a:rPr>
-              <a:t>Measure conversion by account and motion</a:t>
-            </a:r>
-            <a:endParaRPr lang="en-US" sz="1100" dirty="0"/>
-          </a:p>
-        </p:txBody>
-      </p:sp>
-      <p:sp>
-        <p:nvSpPr>
-          <p:cNvPr id="12" name="Text 10"/>
-          <p:cNvSpPr txBox="1"/>
-          <p:nvPr/>
-        </p:nvSpPr>
-        <p:spPr>
-          <a:xfrm>
-            <a:off x="3520440" y="3794760"/>
-            <a:ext cx="2148840" cy="457200"/>
-          </a:xfrm>
-          <a:prstGeom prst="rect">
-            <a:avLst/>
-          </a:prstGeom>
-          <a:noFill/>
-          <a:ln/>
-        </p:spPr>
-        <p:txBody>
-          <a:bodyPr wrap="square" lIns="0" tIns="0" rIns="0" bIns="0" rtlCol="0" anchor="ctr"/>
-          <a:lstStyle/>
-          <a:p>
-            <a:pPr indent="0" marL="0">
-              <a:buNone/>
-            </a:pPr>
-            <a:r>
-              <a:rPr lang="en-US" sz="900" dirty="0">
-                <a:solidFill>
-                  <a:srgbClr val="8E98A3"/>
-                </a:solidFill>
-                <a:latin typeface="Consolas" pitchFamily="34" charset="0"/>
-                <a:ea typeface="Consolas" pitchFamily="34" charset="-122"/>
-                <a:cs typeface="Consolas" pitchFamily="34" charset="-120"/>
-              </a:rPr>
-              <a:t>GATE  </a:t>
-            </a:r>
-            <a:pPr indent="0" marL="0">
-              <a:buNone/>
-            </a:pPr>
-            <a:r>
-              <a:rPr lang="en-US" sz="1100" b="1" dirty="0">
-                <a:solidFill>
-                  <a:srgbClr val="F2F4F6"/>
-                </a:solidFill>
-                <a:latin typeface="Segoe UI" pitchFamily="34" charset="0"/>
-                <a:ea typeface="Segoe UI" pitchFamily="34" charset="-122"/>
-                <a:cs typeface="Segoe UI" pitchFamily="34" charset="-120"/>
-              </a:rPr>
-              <a:t>Evaluations live, with criteria and dates</a:t>
-            </a:r>
-            <a:endParaRPr lang="en-US" sz="1100" dirty="0"/>
-          </a:p>
-        </p:txBody>
-      </p:sp>
-      <p:sp>
-        <p:nvSpPr>
-          <p:cNvPr id="13" name="Shape 11"/>
+          <p:cNvPr id="10" name="Shape 8"/>
           <p:cNvSpPr/>
           <p:nvPr/>
         </p:nvSpPr>
         <p:spPr>
           <a:xfrm>
-            <a:off x="6035040" y="1371600"/>
-            <a:ext cx="2468880" cy="3017520"/>
+            <a:off x="640080" y="1371600"/>
+            <a:ext cx="3794760" cy="2240280"/>
           </a:xfrm>
           <a:prstGeom prst="rect">
             <a:avLst/>
@@ -3309,14 +3203,14 @@
       </p:sp>
       <p:sp>
         <p:nvSpPr>
-          <p:cNvPr id="14" name="Text 12"/>
-          <p:cNvSpPr txBox="1"/>
-          <p:nvPr/>
-        </p:nvSpPr>
-        <p:spPr>
-          <a:xfrm>
-            <a:off x="6217920" y="1508760"/>
-            <a:ext cx="2148840" cy="274320"/>
+          <p:cNvPr id="11" name="Text 9"/>
+          <p:cNvSpPr txBox="1"/>
+          <p:nvPr/>
+        </p:nvSpPr>
+        <p:spPr>
+          <a:xfrm>
+            <a:off x="868680" y="1508760"/>
+            <a:ext cx="3383280" cy="256032"/>
           </a:xfrm>
           <a:prstGeom prst="rect">
             <a:avLst/>
@@ -3332,7 +3226,7 @@
               <a:buNone/>
             </a:pPr>
             <a:r>
-              <a:rPr lang="en-US" sz="900" dirty="0">
+              <a:rPr lang="en-US" sz="950" dirty="0">
                 <a:solidFill>
                   <a:srgbClr val="F05A55"/>
                 </a:solidFill>
@@ -3340,22 +3234,22 @@
                 <a:ea typeface="Consolas" pitchFamily="34" charset="-122"/>
                 <a:cs typeface="Consolas" pitchFamily="34" charset="-120"/>
               </a:rPr>
-              <a:t>DAYS 61–90 · COMMITMENT</a:t>
-            </a:r>
-            <a:endParaRPr lang="en-US" sz="900" dirty="0"/>
-          </a:p>
-        </p:txBody>
-      </p:sp>
-      <p:sp>
-        <p:nvSpPr>
-          <p:cNvPr id="15" name="Text 13"/>
-          <p:cNvSpPr txBox="1"/>
-          <p:nvPr/>
-        </p:nvSpPr>
-        <p:spPr>
-          <a:xfrm>
-            <a:off x="6217920" y="1874520"/>
-            <a:ext cx="2148840" cy="1828800"/>
+              <a:t>EXISTING BUSINESS</a:t>
+            </a:r>
+            <a:endParaRPr lang="en-US" sz="950" dirty="0"/>
+          </a:p>
+        </p:txBody>
+      </p:sp>
+      <p:sp>
+        <p:nvSpPr>
+          <p:cNvPr id="12" name="Text 10"/>
+          <p:cNvSpPr txBox="1"/>
+          <p:nvPr/>
+        </p:nvSpPr>
+        <p:spPr>
+          <a:xfrm>
+            <a:off x="868680" y="1847088"/>
+            <a:ext cx="3383280" cy="1645920"/>
           </a:xfrm>
           <a:prstGeom prst="rect">
             <a:avLst/>
@@ -3369,13 +3263,13 @@
           <a:p>
             <a:pPr marL="342900" indent="-342900">
               <a:spcAft>
-                <a:spcPts val="600"/>
+                <a:spcPts val="700"/>
               </a:spcAft>
               <a:buSzPct val="100000"/>
               <a:buChar char="•"/>
             </a:pPr>
             <a:r>
-              <a:rPr lang="en-US" sz="1100" dirty="0">
+              <a:rPr lang="en-US" sz="1200" dirty="0">
                 <a:solidFill>
                   <a:srgbClr val="C9CED4"/>
                 </a:solidFill>
@@ -3383,20 +3277,20 @@
                 <a:ea typeface="Segoe UI" pitchFamily="34" charset="-122"/>
                 <a:cs typeface="Segoe UI" pitchFamily="34" charset="-120"/>
               </a:rPr>
-              <a:t>Every priority account: advance, nurture or stop</a:t>
-            </a:r>
-            <a:endParaRPr lang="en-US" sz="1100" dirty="0"/>
+              <a:t>Meet every current customer: what are you designing next?</a:t>
+            </a:r>
+            <a:endParaRPr lang="en-US" sz="1200" dirty="0"/>
           </a:p>
           <a:p>
             <a:pPr marL="342900" indent="-342900">
               <a:spcAft>
-                <a:spcPts val="600"/>
+                <a:spcPts val="700"/>
               </a:spcAft>
               <a:buSzPct val="100000"/>
               <a:buChar char="•"/>
             </a:pPr>
             <a:r>
-              <a:rPr lang="en-US" sz="1100" dirty="0">
+              <a:rPr lang="en-US" sz="1200" dirty="0">
                 <a:solidFill>
                   <a:srgbClr val="C9CED4"/>
                 </a:solidFill>
@@ -3404,20 +3298,20 @@
                 <a:ea typeface="Segoe UI" pitchFamily="34" charset="-122"/>
                 <a:cs typeface="Segoe UI" pitchFamily="34" charset="-120"/>
               </a:rPr>
-              <a:t>Design-in decisions where the customer's clock allows</a:t>
-            </a:r>
-            <a:endParaRPr lang="en-US" sz="1100" dirty="0"/>
+              <a:t>Map renewals, expansion potential and accounts at risk</a:t>
+            </a:r>
+            <a:endParaRPr lang="en-US" sz="1200" dirty="0"/>
           </a:p>
           <a:p>
             <a:pPr marL="342900" indent="-342900">
               <a:spcAft>
-                <a:spcPts val="600"/>
+                <a:spcPts val="700"/>
               </a:spcAft>
               <a:buSzPct val="100000"/>
               <a:buChar char="•"/>
             </a:pPr>
             <a:r>
-              <a:rPr lang="en-US" sz="1100" dirty="0">
+              <a:rPr lang="en-US" sz="1200" dirty="0">
                 <a:solidFill>
                   <a:srgbClr val="C9CED4"/>
                 </a:solidFill>
@@ -3425,22 +3319,47 @@
                 <a:ea typeface="Segoe UI" pitchFamily="34" charset="-122"/>
                 <a:cs typeface="Segoe UI" pitchFamily="34" charset="-120"/>
               </a:rPr>
-              <a:t>Bottom-up forecast, every input labelled</a:t>
-            </a:r>
-            <a:endParaRPr lang="en-US" sz="1100" dirty="0"/>
-          </a:p>
-        </p:txBody>
-      </p:sp>
-      <p:sp>
-        <p:nvSpPr>
-          <p:cNvPr id="16" name="Text 14"/>
-          <p:cNvSpPr txBox="1"/>
-          <p:nvPr/>
-        </p:nvSpPr>
-        <p:spPr>
-          <a:xfrm>
-            <a:off x="6217920" y="3794760"/>
-            <a:ext cx="2148840" cy="457200"/>
+              <a:t>Confirm account ownership with Andy and the US team</a:t>
+            </a:r>
+            <a:endParaRPr lang="en-US" sz="1200" dirty="0"/>
+          </a:p>
+        </p:txBody>
+      </p:sp>
+      <p:sp>
+        <p:nvSpPr>
+          <p:cNvPr id="13" name="Shape 11"/>
+          <p:cNvSpPr/>
+          <p:nvPr/>
+        </p:nvSpPr>
+        <p:spPr>
+          <a:xfrm>
+            <a:off x="4709160" y="1371600"/>
+            <a:ext cx="3794760" cy="2240280"/>
+          </a:xfrm>
+          <a:prstGeom prst="rect">
+            <a:avLst/>
+          </a:prstGeom>
+          <a:solidFill>
+            <a:srgbClr val="171B20"/>
+          </a:solidFill>
+          <a:ln w="9525">
+            <a:solidFill>
+              <a:srgbClr val="2A3139"/>
+            </a:solidFill>
+            <a:prstDash val="solid"/>
+          </a:ln>
+        </p:spPr>
+      </p:sp>
+      <p:sp>
+        <p:nvSpPr>
+          <p:cNvPr id="14" name="Text 12"/>
+          <p:cNvSpPr txBox="1"/>
+          <p:nvPr/>
+        </p:nvSpPr>
+        <p:spPr>
+          <a:xfrm>
+            <a:off x="4937760" y="1508760"/>
+            <a:ext cx="3383280" cy="256032"/>
           </a:xfrm>
           <a:prstGeom prst="rect">
             <a:avLst/>
@@ -3456,21 +3375,170 @@
               <a:buNone/>
             </a:pPr>
             <a:r>
-              <a:rPr lang="en-US" sz="900" dirty="0">
-                <a:solidFill>
-                  <a:srgbClr val="8E98A3"/>
+              <a:rPr lang="en-US" sz="950" dirty="0">
+                <a:solidFill>
+                  <a:srgbClr val="F05A55"/>
                 </a:solidFill>
                 <a:latin typeface="Consolas" pitchFamily="34" charset="0"/>
                 <a:ea typeface="Consolas" pitchFamily="34" charset="-122"/>
                 <a:cs typeface="Consolas" pitchFamily="34" charset="-120"/>
               </a:rPr>
-              <a:t>GATE  </a:t>
-            </a:r>
-            <a:pPr indent="0" marL="0">
-              <a:buNone/>
-            </a:pPr>
-            <a:r>
-              <a:rPr lang="en-US" sz="1100" b="1" dirty="0">
+              <a:t>NEW BUSINESS</a:t>
+            </a:r>
+            <a:endParaRPr lang="en-US" sz="950" dirty="0"/>
+          </a:p>
+        </p:txBody>
+      </p:sp>
+      <p:sp>
+        <p:nvSpPr>
+          <p:cNvPr id="15" name="Text 13"/>
+          <p:cNvSpPr txBox="1"/>
+          <p:nvPr/>
+        </p:nvSpPr>
+        <p:spPr>
+          <a:xfrm>
+            <a:off x="4937760" y="1847088"/>
+            <a:ext cx="3383280" cy="1645920"/>
+          </a:xfrm>
+          <a:prstGeom prst="rect">
+            <a:avLst/>
+          </a:prstGeom>
+          <a:noFill/>
+          <a:ln/>
+        </p:spPr>
+        <p:txBody>
+          <a:bodyPr wrap="square" lIns="0" tIns="0" rIns="0" bIns="0" rtlCol="0" anchor="t"/>
+          <a:lstStyle/>
+          <a:p>
+            <a:pPr marL="342900" indent="-342900">
+              <a:spcAft>
+                <a:spcPts val="700"/>
+              </a:spcAft>
+              <a:buSzPct val="100000"/>
+              <a:buChar char="•"/>
+            </a:pPr>
+            <a:r>
+              <a:rPr lang="en-US" sz="1200" dirty="0">
+                <a:solidFill>
+                  <a:srgbClr val="C9CED4"/>
+                </a:solidFill>
+                <a:latin typeface="Segoe UI" pitchFamily="34" charset="0"/>
+                <a:ea typeface="Segoe UI" pitchFamily="34" charset="-122"/>
+                <a:cs typeface="Segoe UI" pitchFamily="34" charset="-120"/>
+              </a:rPr>
+              <a:t>Reconcile my 840-company map against your CRM</a:t>
+            </a:r>
+            <a:endParaRPr lang="en-US" sz="1200" dirty="0"/>
+          </a:p>
+          <a:p>
+            <a:pPr marL="342900" indent="-342900">
+              <a:spcAft>
+                <a:spcPts val="700"/>
+              </a:spcAft>
+              <a:buSzPct val="100000"/>
+              <a:buChar char="•"/>
+            </a:pPr>
+            <a:r>
+              <a:rPr lang="en-US" sz="1200" dirty="0">
+                <a:solidFill>
+                  <a:srgbClr val="C9CED4"/>
+                </a:solidFill>
+                <a:latin typeface="Segoe UI" pitchFamily="34" charset="0"/>
+                <a:ea typeface="Segoe UI" pitchFamily="34" charset="-122"/>
+                <a:cs typeface="Segoe UI" pitchFamily="34" charset="-120"/>
+              </a:rPr>
+              <a:t>Agree the first 20 target accounts with Andy</a:t>
+            </a:r>
+            <a:endParaRPr lang="en-US" sz="1200" dirty="0"/>
+          </a:p>
+          <a:p>
+            <a:pPr marL="342900" indent="-342900">
+              <a:spcAft>
+                <a:spcPts val="700"/>
+              </a:spcAft>
+              <a:buSzPct val="100000"/>
+              <a:buChar char="•"/>
+            </a:pPr>
+            <a:r>
+              <a:rPr lang="en-US" sz="1200" dirty="0">
+                <a:solidFill>
+                  <a:srgbClr val="C9CED4"/>
+                </a:solidFill>
+                <a:latin typeface="Segoe UI" pitchFamily="34" charset="0"/>
+                <a:ea typeface="Segoe UI" pitchFamily="34" charset="-122"/>
+                <a:cs typeface="Segoe UI" pitchFamily="34" charset="-120"/>
+              </a:rPr>
+              <a:t>Book the first OEM meetings from week two</a:t>
+            </a:r>
+            <a:endParaRPr lang="en-US" sz="1200" dirty="0"/>
+          </a:p>
+        </p:txBody>
+      </p:sp>
+      <p:sp>
+        <p:nvSpPr>
+          <p:cNvPr id="16" name="Shape 14"/>
+          <p:cNvSpPr/>
+          <p:nvPr/>
+        </p:nvSpPr>
+        <p:spPr>
+          <a:xfrm>
+            <a:off x="640080" y="3749040"/>
+            <a:ext cx="7863840" cy="658368"/>
+          </a:xfrm>
+          <a:prstGeom prst="rect">
+            <a:avLst/>
+          </a:prstGeom>
+          <a:solidFill>
+            <a:srgbClr val="3A1F21"/>
+          </a:solidFill>
+          <a:ln w="9525">
+            <a:solidFill>
+              <a:srgbClr val="F05A55"/>
+            </a:solidFill>
+            <a:prstDash val="solid"/>
+          </a:ln>
+        </p:spPr>
+      </p:sp>
+      <p:sp>
+        <p:nvSpPr>
+          <p:cNvPr id="17" name="Text 15"/>
+          <p:cNvSpPr txBox="1"/>
+          <p:nvPr/>
+        </p:nvSpPr>
+        <p:spPr>
+          <a:xfrm>
+            <a:off x="868680" y="3785616"/>
+            <a:ext cx="4480560" cy="585216"/>
+          </a:xfrm>
+          <a:prstGeom prst="rect">
+            <a:avLst/>
+          </a:prstGeom>
+          <a:noFill/>
+          <a:ln/>
+        </p:spPr>
+        <p:txBody>
+          <a:bodyPr wrap="square" lIns="0" tIns="0" rIns="0" bIns="0" rtlCol="0" anchor="ctr"/>
+          <a:lstStyle/>
+          <a:p>
+            <a:pPr indent="0" marL="0">
+              <a:buNone/>
+            </a:pPr>
+            <a:r>
+              <a:rPr lang="en-US" sz="950" dirty="0">
+                <a:solidFill>
+                  <a:srgbClr val="F05A55"/>
+                </a:solidFill>
+                <a:latin typeface="Consolas" pitchFamily="34" charset="0"/>
+                <a:ea typeface="Consolas" pitchFamily="34" charset="-122"/>
+                <a:cs typeface="Consolas" pitchFamily="34" charset="-120"/>
+              </a:rPr>
+              <a:t>GATE   </a:t>
+            </a:r>
+            <a:pPr indent="0" marL="0">
+              <a:buNone/>
+            </a:pPr>
+            <a:r>
+              <a:rPr lang="en-US" sz="1200" b="1" dirty="0">
                 <a:solidFill>
                   <a:srgbClr val="F2F4F6"/>
                 </a:solidFill>
@@ -3478,9 +3546,62 @@
                 <a:ea typeface="Segoe UI" pitchFamily="34" charset="-122"/>
                 <a:cs typeface="Segoe UI" pitchFamily="34" charset="-120"/>
               </a:rPr>
-              <a:t>Customer-backed forecast</a:t>
-            </a:r>
-            <a:endParaRPr lang="en-US" sz="1100" dirty="0"/>
+              <a:t>Agreed baseline: accounts, owners, stage definitions, SE capacity</a:t>
+            </a:r>
+            <a:endParaRPr lang="en-US" sz="1200" dirty="0"/>
+          </a:p>
+        </p:txBody>
+      </p:sp>
+      <p:sp>
+        <p:nvSpPr>
+          <p:cNvPr id="18" name="Text 16"/>
+          <p:cNvSpPr txBox="1"/>
+          <p:nvPr/>
+        </p:nvSpPr>
+        <p:spPr>
+          <a:xfrm>
+            <a:off x="5394960" y="3785616"/>
+            <a:ext cx="2971800" cy="585216"/>
+          </a:xfrm>
+          <a:prstGeom prst="rect">
+            <a:avLst/>
+          </a:prstGeom>
+          <a:noFill/>
+          <a:ln/>
+        </p:spPr>
+        <p:txBody>
+          <a:bodyPr wrap="square" lIns="0" tIns="0" rIns="0" bIns="0" rtlCol="0" anchor="ctr"/>
+          <a:lstStyle/>
+          <a:p>
+            <a:pPr indent="0" marL="0">
+              <a:buNone/>
+            </a:pPr>
+            <a:r>
+              <a:rPr lang="en-US" sz="900" dirty="0">
+                <a:solidFill>
+                  <a:srgbClr val="8E98A3"/>
+                </a:solidFill>
+                <a:latin typeface="Consolas" pitchFamily="34" charset="0"/>
+                <a:ea typeface="Consolas" pitchFamily="34" charset="-122"/>
+                <a:cs typeface="Consolas" pitchFamily="34" charset="-120"/>
+              </a:rPr>
+              <a:t>MEASURED BY   </a:t>
+            </a:r>
+            <a:pPr indent="0" marL="0">
+              <a:buNone/>
+            </a:pPr>
+            <a:r>
+              <a:rPr lang="en-US" sz="1050" dirty="0">
+                <a:solidFill>
+                  <a:srgbClr val="C9CED4"/>
+                </a:solidFill>
+                <a:latin typeface="Segoe UI" pitchFamily="34" charset="0"/>
+                <a:ea typeface="Segoe UI" pitchFamily="34" charset="-122"/>
+                <a:cs typeface="Segoe UI" pitchFamily="34" charset="-120"/>
+              </a:rPr>
+              <a:t>All current accounts met · 20 targets agreed</a:t>
+            </a:r>
+            <a:endParaRPr lang="en-US" sz="1050" dirty="0"/>
           </a:p>
         </p:txBody>
       </p:sp>
@@ -3549,7 +3670,7 @@
                 <a:ea typeface="Consolas" pitchFamily="34" charset="-122"/>
                 <a:cs typeface="Consolas" pitchFamily="34" charset="-120"/>
               </a:rPr>
-              <a:t>DISCUSSION</a:t>
+              <a:t>4 · 30-60-90 · DAYS 31–60</a:t>
             </a:r>
             <a:endParaRPr lang="en-US" sz="950" dirty="0"/>
           </a:p>
@@ -3588,7 +3709,7 @@
                 <a:ea typeface="Segoe UI" pitchFamily="34" charset="-122"/>
                 <a:cs typeface="Segoe UI" pitchFamily="34" charset="-120"/>
               </a:rPr>
-              <a:t>Three questions for you</a:t>
+              <a:t>Days 31–60: put evaluations in engineers' hands</a:t>
             </a:r>
             <a:endParaRPr lang="en-US" sz="2200" dirty="0"/>
           </a:p>
@@ -3596,30 +3717,247 @@
       </p:sp>
       <p:sp>
         <p:nvSpPr>
-          <p:cNvPr id="4" name="Text 2"/>
-          <p:cNvSpPr txBox="1"/>
+          <p:cNvPr id="4" name="Shape 2"/>
+          <p:cNvSpPr/>
+          <p:nvPr/>
+        </p:nvSpPr>
+        <p:spPr>
+          <a:xfrm>
+            <a:off x="7223760" y="329184"/>
+            <a:ext cx="329184" cy="329184"/>
+          </a:xfrm>
+          <a:prstGeom prst="ellipse">
+            <a:avLst/>
+          </a:prstGeom>
+          <a:solidFill>
+            <a:srgbClr val="171B20"/>
+          </a:solidFill>
+          <a:ln w="9525">
+            <a:solidFill>
+              <a:srgbClr val="2A3139"/>
+            </a:solidFill>
+            <a:prstDash val="solid"/>
+          </a:ln>
+        </p:spPr>
+      </p:sp>
+      <p:sp>
+        <p:nvSpPr>
+          <p:cNvPr id="5" name="Text 3"/>
+          <p:cNvSpPr txBox="1"/>
+          <p:nvPr/>
+        </p:nvSpPr>
+        <p:spPr>
+          <a:xfrm>
+            <a:off x="7223760" y="329184"/>
+            <a:ext cx="329184" cy="329184"/>
+          </a:xfrm>
+          <a:prstGeom prst="rect">
+            <a:avLst/>
+          </a:prstGeom>
+          <a:noFill/>
+          <a:ln/>
+        </p:spPr>
+        <p:txBody>
+          <a:bodyPr wrap="square" lIns="0" tIns="0" rIns="0" bIns="0" rtlCol="0" anchor="ctr"/>
+          <a:lstStyle/>
+          <a:p>
+            <a:pPr algn="ctr" indent="0" marL="0">
+              <a:buNone/>
+            </a:pPr>
+            <a:r>
+              <a:rPr lang="en-US" sz="900" b="1" dirty="0">
+                <a:solidFill>
+                  <a:srgbClr val="8E98A3"/>
+                </a:solidFill>
+                <a:latin typeface="Segoe UI" pitchFamily="34" charset="0"/>
+                <a:ea typeface="Segoe UI" pitchFamily="34" charset="-122"/>
+                <a:cs typeface="Segoe UI" pitchFamily="34" charset="-120"/>
+              </a:rPr>
+              <a:t>30</a:t>
+            </a:r>
+            <a:endParaRPr lang="en-US" sz="900" dirty="0"/>
+          </a:p>
+        </p:txBody>
+      </p:sp>
+      <p:sp>
+        <p:nvSpPr>
+          <p:cNvPr id="6" name="Shape 4"/>
+          <p:cNvSpPr/>
+          <p:nvPr/>
+        </p:nvSpPr>
+        <p:spPr>
+          <a:xfrm>
+            <a:off x="7662672" y="329184"/>
+            <a:ext cx="329184" cy="329184"/>
+          </a:xfrm>
+          <a:prstGeom prst="ellipse">
+            <a:avLst/>
+          </a:prstGeom>
+          <a:solidFill>
+            <a:srgbClr val="F05A55"/>
+          </a:solidFill>
+          <a:ln w="9525">
+            <a:solidFill>
+              <a:srgbClr val="F05A55"/>
+            </a:solidFill>
+            <a:prstDash val="solid"/>
+          </a:ln>
+        </p:spPr>
+      </p:sp>
+      <p:sp>
+        <p:nvSpPr>
+          <p:cNvPr id="7" name="Text 5"/>
+          <p:cNvSpPr txBox="1"/>
+          <p:nvPr/>
+        </p:nvSpPr>
+        <p:spPr>
+          <a:xfrm>
+            <a:off x="7662672" y="329184"/>
+            <a:ext cx="329184" cy="329184"/>
+          </a:xfrm>
+          <a:prstGeom prst="rect">
+            <a:avLst/>
+          </a:prstGeom>
+          <a:noFill/>
+          <a:ln/>
+        </p:spPr>
+        <p:txBody>
+          <a:bodyPr wrap="square" lIns="0" tIns="0" rIns="0" bIns="0" rtlCol="0" anchor="ctr"/>
+          <a:lstStyle/>
+          <a:p>
+            <a:pPr algn="ctr" indent="0" marL="0">
+              <a:buNone/>
+            </a:pPr>
+            <a:r>
+              <a:rPr lang="en-US" sz="900" b="1" dirty="0">
+                <a:solidFill>
+                  <a:srgbClr val="0B0D10"/>
+                </a:solidFill>
+                <a:latin typeface="Segoe UI" pitchFamily="34" charset="0"/>
+                <a:ea typeface="Segoe UI" pitchFamily="34" charset="-122"/>
+                <a:cs typeface="Segoe UI" pitchFamily="34" charset="-120"/>
+              </a:rPr>
+              <a:t>60</a:t>
+            </a:r>
+            <a:endParaRPr lang="en-US" sz="900" dirty="0"/>
+          </a:p>
+        </p:txBody>
+      </p:sp>
+      <p:sp>
+        <p:nvSpPr>
+          <p:cNvPr id="8" name="Shape 6"/>
+          <p:cNvSpPr/>
+          <p:nvPr/>
+        </p:nvSpPr>
+        <p:spPr>
+          <a:xfrm>
+            <a:off x="8101584" y="329184"/>
+            <a:ext cx="329184" cy="329184"/>
+          </a:xfrm>
+          <a:prstGeom prst="ellipse">
+            <a:avLst/>
+          </a:prstGeom>
+          <a:solidFill>
+            <a:srgbClr val="171B20"/>
+          </a:solidFill>
+          <a:ln w="9525">
+            <a:solidFill>
+              <a:srgbClr val="2A3139"/>
+            </a:solidFill>
+            <a:prstDash val="solid"/>
+          </a:ln>
+        </p:spPr>
+      </p:sp>
+      <p:sp>
+        <p:nvSpPr>
+          <p:cNvPr id="9" name="Text 7"/>
+          <p:cNvSpPr txBox="1"/>
+          <p:nvPr/>
+        </p:nvSpPr>
+        <p:spPr>
+          <a:xfrm>
+            <a:off x="8101584" y="329184"/>
+            <a:ext cx="329184" cy="329184"/>
+          </a:xfrm>
+          <a:prstGeom prst="rect">
+            <a:avLst/>
+          </a:prstGeom>
+          <a:noFill/>
+          <a:ln/>
+        </p:spPr>
+        <p:txBody>
+          <a:bodyPr wrap="square" lIns="0" tIns="0" rIns="0" bIns="0" rtlCol="0" anchor="ctr"/>
+          <a:lstStyle/>
+          <a:p>
+            <a:pPr algn="ctr" indent="0" marL="0">
+              <a:buNone/>
+            </a:pPr>
+            <a:r>
+              <a:rPr lang="en-US" sz="900" b="1" dirty="0">
+                <a:solidFill>
+                  <a:srgbClr val="8E98A3"/>
+                </a:solidFill>
+                <a:latin typeface="Segoe UI" pitchFamily="34" charset="0"/>
+                <a:ea typeface="Segoe UI" pitchFamily="34" charset="-122"/>
+                <a:cs typeface="Segoe UI" pitchFamily="34" charset="-120"/>
+              </a:rPr>
+              <a:t>90</a:t>
+            </a:r>
+            <a:endParaRPr lang="en-US" sz="900" dirty="0"/>
+          </a:p>
+        </p:txBody>
+      </p:sp>
+      <p:sp>
+        <p:nvSpPr>
+          <p:cNvPr id="10" name="Shape 8"/>
+          <p:cNvSpPr/>
           <p:nvPr/>
         </p:nvSpPr>
         <p:spPr>
           <a:xfrm>
             <a:off x="640080" y="1371600"/>
-            <a:ext cx="1463040" cy="685800"/>
-          </a:xfrm>
-          <a:prstGeom prst="rect">
-            <a:avLst/>
-          </a:prstGeom>
-          <a:noFill/>
-          <a:ln/>
-        </p:spPr>
-        <p:txBody>
-          <a:bodyPr wrap="square" lIns="0" tIns="0" rIns="0" bIns="0" rtlCol="0" anchor="t"/>
-          <a:lstStyle/>
-          <a:p>
-            <a:pPr indent="0" marL="0">
-              <a:buNone/>
-            </a:pPr>
-            <a:r>
-              <a:rPr lang="en-US" sz="1000" dirty="0">
+            <a:ext cx="3794760" cy="2240280"/>
+          </a:xfrm>
+          <a:prstGeom prst="rect">
+            <a:avLst/>
+          </a:prstGeom>
+          <a:solidFill>
+            <a:srgbClr val="171B20"/>
+          </a:solidFill>
+          <a:ln w="9525">
+            <a:solidFill>
+              <a:srgbClr val="2A3139"/>
+            </a:solidFill>
+            <a:prstDash val="solid"/>
+          </a:ln>
+        </p:spPr>
+      </p:sp>
+      <p:sp>
+        <p:nvSpPr>
+          <p:cNvPr id="11" name="Text 9"/>
+          <p:cNvSpPr txBox="1"/>
+          <p:nvPr/>
+        </p:nvSpPr>
+        <p:spPr>
+          <a:xfrm>
+            <a:off x="868680" y="1508760"/>
+            <a:ext cx="3383280" cy="256032"/>
+          </a:xfrm>
+          <a:prstGeom prst="rect">
+            <a:avLst/>
+          </a:prstGeom>
+          <a:noFill/>
+          <a:ln/>
+        </p:spPr>
+        <p:txBody>
+          <a:bodyPr wrap="square" lIns="0" tIns="0" rIns="0" bIns="0" rtlCol="0" anchor="ctr"/>
+          <a:lstStyle/>
+          <a:p>
+            <a:pPr indent="0" marL="0">
+              <a:buNone/>
+            </a:pPr>
+            <a:r>
+              <a:rPr lang="en-US" sz="950" dirty="0">
                 <a:solidFill>
                   <a:srgbClr val="F05A55"/>
                 </a:solidFill>
@@ -3627,22 +3965,22 @@
                 <a:ea typeface="Consolas" pitchFamily="34" charset="-122"/>
                 <a:cs typeface="Consolas" pitchFamily="34" charset="-120"/>
               </a:rPr>
-              <a:t>GROWTH</a:t>
-            </a:r>
-            <a:endParaRPr lang="en-US" sz="1000" dirty="0"/>
-          </a:p>
-        </p:txBody>
-      </p:sp>
-      <p:sp>
-        <p:nvSpPr>
-          <p:cNvPr id="5" name="Text 3"/>
-          <p:cNvSpPr txBox="1"/>
-          <p:nvPr/>
-        </p:nvSpPr>
-        <p:spPr>
-          <a:xfrm>
-            <a:off x="2194560" y="1371600"/>
-            <a:ext cx="6309360" cy="685800"/>
+              <a:t>EXISTING BUSINESS</a:t>
+            </a:r>
+            <a:endParaRPr lang="en-US" sz="950" dirty="0"/>
+          </a:p>
+        </p:txBody>
+      </p:sp>
+      <p:sp>
+        <p:nvSpPr>
+          <p:cNvPr id="12" name="Text 10"/>
+          <p:cNvSpPr txBox="1"/>
+          <p:nvPr/>
+        </p:nvSpPr>
+        <p:spPr>
+          <a:xfrm>
+            <a:off x="868680" y="1847088"/>
+            <a:ext cx="3383280" cy="1645920"/>
           </a:xfrm>
           <a:prstGeom prst="rect">
             <a:avLst/>
@@ -3654,50 +3992,121 @@
           <a:bodyPr wrap="square" lIns="0" tIns="0" rIns="0" bIns="0" rtlCol="0" anchor="t"/>
           <a:lstStyle/>
           <a:p>
-            <a:pPr indent="0" marL="0">
-              <a:buNone/>
-            </a:pPr>
-            <a:r>
-              <a:rPr lang="en-US" sz="1300" dirty="0">
-                <a:solidFill>
-                  <a:srgbClr val="F2F4F6"/>
-                </a:solidFill>
-                <a:latin typeface="Segoe UI" pitchFamily="34" charset="0"/>
-                <a:ea typeface="Segoe UI" pitchFamily="34" charset="-122"/>
-                <a:cs typeface="Segoe UI" pitchFamily="34" charset="-120"/>
-              </a:rPr>
-              <a:t>Is Europe mainly a new-logo build, expansion inside platforms you're already on, or a real step-up in regional revenue?</a:t>
-            </a:r>
-            <a:endParaRPr lang="en-US" sz="1300" dirty="0"/>
-          </a:p>
-        </p:txBody>
-      </p:sp>
-      <p:sp>
-        <p:nvSpPr>
-          <p:cNvPr id="6" name="Text 4"/>
-          <p:cNvSpPr txBox="1"/>
-          <p:nvPr/>
-        </p:nvSpPr>
-        <p:spPr>
-          <a:xfrm>
-            <a:off x="640080" y="2240280"/>
-            <a:ext cx="1463040" cy="685800"/>
-          </a:xfrm>
-          <a:prstGeom prst="rect">
-            <a:avLst/>
-          </a:prstGeom>
-          <a:noFill/>
-          <a:ln/>
-        </p:spPr>
-        <p:txBody>
-          <a:bodyPr wrap="square" lIns="0" tIns="0" rIns="0" bIns="0" rtlCol="0" anchor="t"/>
-          <a:lstStyle/>
-          <a:p>
-            <a:pPr indent="0" marL="0">
-              <a:buNone/>
-            </a:pPr>
-            <a:r>
-              <a:rPr lang="en-US" sz="1000" dirty="0">
+            <a:pPr marL="342900" indent="-342900">
+              <a:spcAft>
+                <a:spcPts val="700"/>
+              </a:spcAft>
+              <a:buSzPct val="100000"/>
+              <a:buChar char="•"/>
+            </a:pPr>
+            <a:r>
+              <a:rPr lang="en-US" sz="1200" dirty="0">
+                <a:solidFill>
+                  <a:srgbClr val="C9CED4"/>
+                </a:solidFill>
+                <a:latin typeface="Segoe UI" pitchFamily="34" charset="0"/>
+                <a:ea typeface="Segoe UI" pitchFamily="34" charset="-122"/>
+                <a:cs typeface="Segoe UI" pitchFamily="34" charset="-120"/>
+              </a:rPr>
+              <a:t>Expansion plan for each top account: next platform, second band</a:t>
+            </a:r>
+            <a:endParaRPr lang="en-US" sz="1200" dirty="0"/>
+          </a:p>
+          <a:p>
+            <a:pPr marL="342900" indent="-342900">
+              <a:spcAft>
+                <a:spcPts val="700"/>
+              </a:spcAft>
+              <a:buSzPct val="100000"/>
+              <a:buChar char="•"/>
+            </a:pPr>
+            <a:r>
+              <a:rPr lang="en-US" sz="1200" dirty="0">
+                <a:solidFill>
+                  <a:srgbClr val="C9CED4"/>
+                </a:solidFill>
+                <a:latin typeface="Segoe UI" pitchFamily="34" charset="0"/>
+                <a:ea typeface="Segoe UI" pitchFamily="34" charset="-122"/>
+                <a:cs typeface="Segoe UI" pitchFamily="34" charset="-120"/>
+              </a:rPr>
+              <a:t>Resolve anything at risk before it reaches the forecast</a:t>
+            </a:r>
+            <a:endParaRPr lang="en-US" sz="1200" dirty="0"/>
+          </a:p>
+          <a:p>
+            <a:pPr marL="342900" indent="-342900">
+              <a:spcAft>
+                <a:spcPts val="700"/>
+              </a:spcAft>
+              <a:buSzPct val="100000"/>
+              <a:buChar char="•"/>
+            </a:pPr>
+            <a:r>
+              <a:rPr lang="en-US" sz="1200" dirty="0">
+                <a:solidFill>
+                  <a:srgbClr val="C9CED4"/>
+                </a:solidFill>
+                <a:latin typeface="Segoe UI" pitchFamily="34" charset="0"/>
+                <a:ea typeface="Segoe UI" pitchFamily="34" charset="-122"/>
+                <a:cs typeface="Segoe UI" pitchFamily="34" charset="-120"/>
+              </a:rPr>
+              <a:t>Use current customers as references for new logos</a:t>
+            </a:r>
+            <a:endParaRPr lang="en-US" sz="1200" dirty="0"/>
+          </a:p>
+        </p:txBody>
+      </p:sp>
+      <p:sp>
+        <p:nvSpPr>
+          <p:cNvPr id="13" name="Shape 11"/>
+          <p:cNvSpPr/>
+          <p:nvPr/>
+        </p:nvSpPr>
+        <p:spPr>
+          <a:xfrm>
+            <a:off x="4709160" y="1371600"/>
+            <a:ext cx="3794760" cy="2240280"/>
+          </a:xfrm>
+          <a:prstGeom prst="rect">
+            <a:avLst/>
+          </a:prstGeom>
+          <a:solidFill>
+            <a:srgbClr val="171B20"/>
+          </a:solidFill>
+          <a:ln w="9525">
+            <a:solidFill>
+              <a:srgbClr val="2A3139"/>
+            </a:solidFill>
+            <a:prstDash val="solid"/>
+          </a:ln>
+        </p:spPr>
+      </p:sp>
+      <p:sp>
+        <p:nvSpPr>
+          <p:cNvPr id="14" name="Text 12"/>
+          <p:cNvSpPr txBox="1"/>
+          <p:nvPr/>
+        </p:nvSpPr>
+        <p:spPr>
+          <a:xfrm>
+            <a:off x="4937760" y="1508760"/>
+            <a:ext cx="3383280" cy="256032"/>
+          </a:xfrm>
+          <a:prstGeom prst="rect">
+            <a:avLst/>
+          </a:prstGeom>
+          <a:noFill/>
+          <a:ln/>
+        </p:spPr>
+        <p:txBody>
+          <a:bodyPr wrap="square" lIns="0" tIns="0" rIns="0" bIns="0" rtlCol="0" anchor="ctr"/>
+          <a:lstStyle/>
+          <a:p>
+            <a:pPr indent="0" marL="0">
+              <a:buNone/>
+            </a:pPr>
+            <a:r>
+              <a:rPr lang="en-US" sz="950" dirty="0">
                 <a:solidFill>
                   <a:srgbClr val="F05A55"/>
                 </a:solidFill>
@@ -3705,22 +4114,22 @@
                 <a:ea typeface="Consolas" pitchFamily="34" charset="-122"/>
                 <a:cs typeface="Consolas" pitchFamily="34" charset="-120"/>
               </a:rPr>
-              <a:t>OWNERSHIP</a:t>
-            </a:r>
-            <a:endParaRPr lang="en-US" sz="1000" dirty="0"/>
-          </a:p>
-        </p:txBody>
-      </p:sp>
-      <p:sp>
-        <p:nvSpPr>
-          <p:cNvPr id="7" name="Text 5"/>
-          <p:cNvSpPr txBox="1"/>
-          <p:nvPr/>
-        </p:nvSpPr>
-        <p:spPr>
-          <a:xfrm>
-            <a:off x="2194560" y="2240280"/>
-            <a:ext cx="6309360" cy="685800"/>
+              <a:t>NEW BUSINESS</a:t>
+            </a:r>
+            <a:endParaRPr lang="en-US" sz="950" dirty="0"/>
+          </a:p>
+        </p:txBody>
+      </p:sp>
+      <p:sp>
+        <p:nvSpPr>
+          <p:cNvPr id="15" name="Text 13"/>
+          <p:cNvSpPr txBox="1"/>
+          <p:nvPr/>
+        </p:nvSpPr>
+        <p:spPr>
+          <a:xfrm>
+            <a:off x="4937760" y="1847088"/>
+            <a:ext cx="3383280" cy="1645920"/>
           </a:xfrm>
           <a:prstGeom prst="rect">
             <a:avLst/>
@@ -3732,50 +4141,121 @@
           <a:bodyPr wrap="square" lIns="0" tIns="0" rIns="0" bIns="0" rtlCol="0" anchor="t"/>
           <a:lstStyle/>
           <a:p>
-            <a:pPr indent="0" marL="0">
-              <a:buNone/>
-            </a:pPr>
-            <a:r>
-              <a:rPr lang="en-US" sz="1300" dirty="0">
-                <a:solidFill>
-                  <a:srgbClr val="F2F4F6"/>
-                </a:solidFill>
-                <a:latin typeface="Segoe UI" pitchFamily="34" charset="0"/>
-                <a:ea typeface="Segoe UI" pitchFamily="34" charset="-122"/>
-                <a:cs typeface="Segoe UI" pitchFamily="34" charset="-120"/>
-              </a:rPr>
-              <a:t>When a high-value OEM sits across a border, does ownership follow geography, relationships, or whoever is best placed to win the design-in?</a:t>
-            </a:r>
-            <a:endParaRPr lang="en-US" sz="1300" dirty="0"/>
-          </a:p>
-        </p:txBody>
-      </p:sp>
-      <p:sp>
-        <p:nvSpPr>
-          <p:cNvPr id="8" name="Text 6"/>
-          <p:cNvSpPr txBox="1"/>
-          <p:nvPr/>
-        </p:nvSpPr>
-        <p:spPr>
-          <a:xfrm>
-            <a:off x="640080" y="3108960"/>
-            <a:ext cx="1463040" cy="685800"/>
-          </a:xfrm>
-          <a:prstGeom prst="rect">
-            <a:avLst/>
-          </a:prstGeom>
-          <a:noFill/>
-          <a:ln/>
-        </p:spPr>
-        <p:txBody>
-          <a:bodyPr wrap="square" lIns="0" tIns="0" rIns="0" bIns="0" rtlCol="0" anchor="t"/>
-          <a:lstStyle/>
-          <a:p>
-            <a:pPr indent="0" marL="0">
-              <a:buNone/>
-            </a:pPr>
-            <a:r>
-              <a:rPr lang="en-US" sz="1000" dirty="0">
+            <a:pPr marL="342900" indent="-342900">
+              <a:spcAft>
+                <a:spcPts val="700"/>
+              </a:spcAft>
+              <a:buSzPct val="100000"/>
+              <a:buChar char="•"/>
+            </a:pPr>
+            <a:r>
+              <a:rPr lang="en-US" sz="1200" dirty="0">
+                <a:solidFill>
+                  <a:srgbClr val="C9CED4"/>
+                </a:solidFill>
+                <a:latin typeface="Segoe UI" pitchFamily="34" charset="0"/>
+                <a:ea typeface="Segoe UI" pitchFamily="34" charset="-122"/>
+                <a:cs typeface="Segoe UI" pitchFamily="34" charset="-120"/>
+              </a:rPr>
+              <a:t>4–6 evaluations with written success criteria and a decision date</a:t>
+            </a:r>
+            <a:endParaRPr lang="en-US" sz="1200" dirty="0"/>
+          </a:p>
+          <a:p>
+            <a:pPr marL="342900" indent="-342900">
+              <a:spcAft>
+                <a:spcPts val="700"/>
+              </a:spcAft>
+              <a:buSzPct val="100000"/>
+              <a:buChar char="•"/>
+            </a:pPr>
+            <a:r>
+              <a:rPr lang="en-US" sz="1200" dirty="0">
+                <a:solidFill>
+                  <a:srgbClr val="C9CED4"/>
+                </a:solidFill>
+                <a:latin typeface="Segoe UI" pitchFamily="34" charset="0"/>
+                <a:ea typeface="Segoe UI" pitchFamily="34" charset="-122"/>
+                <a:cs typeface="Segoe UI" pitchFamily="34" charset="-120"/>
+              </a:rPr>
+              <a:t>Sized to Sales Engineering capacity; the rest wait in a qualified queue</a:t>
+            </a:r>
+            <a:endParaRPr lang="en-US" sz="1200" dirty="0"/>
+          </a:p>
+          <a:p>
+            <a:pPr marL="342900" indent="-342900">
+              <a:spcAft>
+                <a:spcPts val="700"/>
+              </a:spcAft>
+              <a:buSzPct val="100000"/>
+              <a:buChar char="•"/>
+            </a:pPr>
+            <a:r>
+              <a:rPr lang="en-US" sz="1200" dirty="0">
+                <a:solidFill>
+                  <a:srgbClr val="C9CED4"/>
+                </a:solidFill>
+                <a:latin typeface="Segoe UI" pitchFamily="34" charset="0"/>
+                <a:ea typeface="Segoe UI" pitchFamily="34" charset="-122"/>
+                <a:cs typeface="Segoe UI" pitchFamily="34" charset="-120"/>
+              </a:rPr>
+              <a:t>1–2 partners in bounded pilots: named accounts, deal registration</a:t>
+            </a:r>
+            <a:endParaRPr lang="en-US" sz="1200" dirty="0"/>
+          </a:p>
+        </p:txBody>
+      </p:sp>
+      <p:sp>
+        <p:nvSpPr>
+          <p:cNvPr id="16" name="Shape 14"/>
+          <p:cNvSpPr/>
+          <p:nvPr/>
+        </p:nvSpPr>
+        <p:spPr>
+          <a:xfrm>
+            <a:off x="640080" y="3749040"/>
+            <a:ext cx="7863840" cy="658368"/>
+          </a:xfrm>
+          <a:prstGeom prst="rect">
+            <a:avLst/>
+          </a:prstGeom>
+          <a:solidFill>
+            <a:srgbClr val="3A1F21"/>
+          </a:solidFill>
+          <a:ln w="9525">
+            <a:solidFill>
+              <a:srgbClr val="F05A55"/>
+            </a:solidFill>
+            <a:prstDash val="solid"/>
+          </a:ln>
+        </p:spPr>
+      </p:sp>
+      <p:sp>
+        <p:nvSpPr>
+          <p:cNvPr id="17" name="Text 15"/>
+          <p:cNvSpPr txBox="1"/>
+          <p:nvPr/>
+        </p:nvSpPr>
+        <p:spPr>
+          <a:xfrm>
+            <a:off x="868680" y="3785616"/>
+            <a:ext cx="4480560" cy="585216"/>
+          </a:xfrm>
+          <a:prstGeom prst="rect">
+            <a:avLst/>
+          </a:prstGeom>
+          <a:noFill/>
+          <a:ln/>
+        </p:spPr>
+        <p:txBody>
+          <a:bodyPr wrap="square" lIns="0" tIns="0" rIns="0" bIns="0" rtlCol="0" anchor="ctr"/>
+          <a:lstStyle/>
+          <a:p>
+            <a:pPr indent="0" marL="0">
+              <a:buNone/>
+            </a:pPr>
+            <a:r>
+              <a:rPr lang="en-US" sz="950" dirty="0">
                 <a:solidFill>
                   <a:srgbClr val="F05A55"/>
                 </a:solidFill>
@@ -3783,38 +4263,13 @@
                 <a:ea typeface="Consolas" pitchFamily="34" charset="-122"/>
                 <a:cs typeface="Consolas" pitchFamily="34" charset="-120"/>
               </a:rPr>
-              <a:t>SUCCESS</a:t>
-            </a:r>
-            <a:endParaRPr lang="en-US" sz="1000" dirty="0"/>
-          </a:p>
-        </p:txBody>
-      </p:sp>
-      <p:sp>
-        <p:nvSpPr>
-          <p:cNvPr id="9" name="Text 7"/>
-          <p:cNvSpPr txBox="1"/>
-          <p:nvPr/>
-        </p:nvSpPr>
-        <p:spPr>
-          <a:xfrm>
-            <a:off x="2194560" y="3108960"/>
-            <a:ext cx="6309360" cy="685800"/>
-          </a:xfrm>
-          <a:prstGeom prst="rect">
-            <a:avLst/>
-          </a:prstGeom>
-          <a:noFill/>
-          <a:ln/>
-        </p:spPr>
-        <p:txBody>
-          <a:bodyPr wrap="square" lIns="0" tIns="0" rIns="0" bIns="0" rtlCol="0" anchor="t"/>
-          <a:lstStyle/>
-          <a:p>
-            <a:pPr indent="0" marL="0">
-              <a:buNone/>
-            </a:pPr>
-            <a:r>
-              <a:rPr lang="en-US" sz="1300" dirty="0">
+              <a:t>GATE   </a:t>
+            </a:r>
+            <a:pPr indent="0" marL="0">
+              <a:buNone/>
+            </a:pPr>
+            <a:r>
+              <a:rPr lang="en-US" sz="1200" b="1" dirty="0">
                 <a:solidFill>
                   <a:srgbClr val="F2F4F6"/>
                 </a:solidFill>
@@ -3822,22 +4277,22 @@
                 <a:ea typeface="Segoe UI" pitchFamily="34" charset="-122"/>
                 <a:cs typeface="Segoe UI" pitchFamily="34" charset="-120"/>
               </a:rPr>
-              <a:t>Twelve months from now, what would make you say this role clearly exceeded expectations?</a:t>
-            </a:r>
-            <a:endParaRPr lang="en-US" sz="1300" dirty="0"/>
-          </a:p>
-        </p:txBody>
-      </p:sp>
-      <p:sp>
-        <p:nvSpPr>
-          <p:cNvPr id="10" name="Text 8"/>
-          <p:cNvSpPr txBox="1"/>
-          <p:nvPr/>
-        </p:nvSpPr>
-        <p:spPr>
-          <a:xfrm>
-            <a:off x="640080" y="4160520"/>
-            <a:ext cx="7863840" cy="457200"/>
+              <a:t>Evaluations live, each with criteria, an owner and a date</a:t>
+            </a:r>
+            <a:endParaRPr lang="en-US" sz="1200" dirty="0"/>
+          </a:p>
+        </p:txBody>
+      </p:sp>
+      <p:sp>
+        <p:nvSpPr>
+          <p:cNvPr id="18" name="Text 16"/>
+          <p:cNvSpPr txBox="1"/>
+          <p:nvPr/>
+        </p:nvSpPr>
+        <p:spPr>
+          <a:xfrm>
+            <a:off x="5394960" y="3785616"/>
+            <a:ext cx="2971800" cy="585216"/>
           </a:xfrm>
           <a:prstGeom prst="rect">
             <a:avLst/>
@@ -3853,17 +4308,31 @@
               <a:buNone/>
             </a:pPr>
             <a:r>
-              <a:rPr lang="en-US" sz="1400" b="1" dirty="0">
-                <a:solidFill>
-                  <a:srgbClr val="F2F4F6"/>
-                </a:solidFill>
-                <a:latin typeface="Segoe UI" pitchFamily="34" charset="0"/>
-                <a:ea typeface="Segoe UI" pitchFamily="34" charset="-122"/>
-                <a:cs typeface="Segoe UI" pitchFamily="34" charset="-120"/>
-              </a:rPr>
-              <a:t>Give me the account list and 90 days — you'll have a forecast where every number has a source.</a:t>
-            </a:r>
-            <a:endParaRPr lang="en-US" sz="1400" dirty="0"/>
+              <a:rPr lang="en-US" sz="900" dirty="0">
+                <a:solidFill>
+                  <a:srgbClr val="8E98A3"/>
+                </a:solidFill>
+                <a:latin typeface="Consolas" pitchFamily="34" charset="0"/>
+                <a:ea typeface="Consolas" pitchFamily="34" charset="-122"/>
+                <a:cs typeface="Consolas" pitchFamily="34" charset="-120"/>
+              </a:rPr>
+              <a:t>MEASURED BY   </a:t>
+            </a:r>
+            <a:pPr indent="0" marL="0">
+              <a:buNone/>
+            </a:pPr>
+            <a:r>
+              <a:rPr lang="en-US" sz="1050" dirty="0">
+                <a:solidFill>
+                  <a:srgbClr val="C9CED4"/>
+                </a:solidFill>
+                <a:latin typeface="Segoe UI" pitchFamily="34" charset="0"/>
+                <a:ea typeface="Segoe UI" pitchFamily="34" charset="-122"/>
+                <a:cs typeface="Segoe UI" pitchFamily="34" charset="-120"/>
+              </a:rPr>
+              <a:t>Evaluations started · stage age · partner milestones</a:t>
+            </a:r>
+            <a:endParaRPr lang="en-US" sz="1050" dirty="0"/>
           </a:p>
         </p:txBody>
       </p:sp>
@@ -3932,6 +4401,1120 @@
                 <a:ea typeface="Consolas" pitchFamily="34" charset="-122"/>
                 <a:cs typeface="Consolas" pitchFamily="34" charset="-120"/>
               </a:rPr>
+              <a:t>4 · 30-60-90 · DAYS 61–90</a:t>
+            </a:r>
+            <a:endParaRPr lang="en-US" sz="950" dirty="0"/>
+          </a:p>
+        </p:txBody>
+      </p:sp>
+      <p:sp>
+        <p:nvSpPr>
+          <p:cNvPr id="3" name="Text 1"/>
+          <p:cNvSpPr txBox="1"/>
+          <p:nvPr/>
+        </p:nvSpPr>
+        <p:spPr>
+          <a:xfrm>
+            <a:off x="640080" y="658368"/>
+            <a:ext cx="7863840" cy="566928"/>
+          </a:xfrm>
+          <a:prstGeom prst="rect">
+            <a:avLst/>
+          </a:prstGeom>
+          <a:noFill/>
+          <a:ln/>
+        </p:spPr>
+        <p:txBody>
+          <a:bodyPr wrap="square" lIns="0" tIns="0" rIns="0" bIns="0" rtlCol="0" anchor="t"/>
+          <a:lstStyle/>
+          <a:p>
+            <a:pPr indent="0" marL="0">
+              <a:buNone/>
+            </a:pPr>
+            <a:r>
+              <a:rPr lang="en-US" sz="2200" b="1" dirty="0">
+                <a:solidFill>
+                  <a:srgbClr val="F2F4F6"/>
+                </a:solidFill>
+                <a:latin typeface="Segoe UI" pitchFamily="34" charset="0"/>
+                <a:ea typeface="Segoe UI" pitchFamily="34" charset="-122"/>
+                <a:cs typeface="Segoe UI" pitchFamily="34" charset="-120"/>
+              </a:rPr>
+              <a:t>Days 61–90: turn evidence into a forecast</a:t>
+            </a:r>
+            <a:endParaRPr lang="en-US" sz="2200" dirty="0"/>
+          </a:p>
+        </p:txBody>
+      </p:sp>
+      <p:sp>
+        <p:nvSpPr>
+          <p:cNvPr id="4" name="Text 2"/>
+          <p:cNvSpPr txBox="1"/>
+          <p:nvPr/>
+        </p:nvSpPr>
+        <p:spPr>
+          <a:xfrm>
+            <a:off x="640080" y="4590288"/>
+            <a:ext cx="7863840" cy="256032"/>
+          </a:xfrm>
+          <a:prstGeom prst="rect">
+            <a:avLst/>
+          </a:prstGeom>
+          <a:noFill/>
+          <a:ln/>
+        </p:spPr>
+        <p:txBody>
+          <a:bodyPr wrap="square" lIns="0" tIns="0" rIns="0" bIns="0" rtlCol="0" anchor="ctr"/>
+          <a:lstStyle/>
+          <a:p>
+            <a:pPr indent="0" marL="0">
+              <a:buNone/>
+            </a:pPr>
+            <a:r>
+              <a:rPr lang="en-US" sz="950" dirty="0">
+                <a:solidFill>
+                  <a:srgbClr val="F05A55"/>
+                </a:solidFill>
+                <a:latin typeface="Segoe UI" pitchFamily="34" charset="0"/>
+                <a:ea typeface="Segoe UI" pitchFamily="34" charset="-122"/>
+                <a:cs typeface="Segoe UI" pitchFamily="34" charset="-120"/>
+              </a:rPr>
+              <a:t>No production wins promised in 90 days: the design-in cycle is longer than that.</a:t>
+            </a:r>
+            <a:endParaRPr lang="en-US" sz="950" dirty="0"/>
+          </a:p>
+        </p:txBody>
+      </p:sp>
+      <p:sp>
+        <p:nvSpPr>
+          <p:cNvPr id="5" name="Shape 3"/>
+          <p:cNvSpPr/>
+          <p:nvPr/>
+        </p:nvSpPr>
+        <p:spPr>
+          <a:xfrm>
+            <a:off x="7223760" y="329184"/>
+            <a:ext cx="329184" cy="329184"/>
+          </a:xfrm>
+          <a:prstGeom prst="ellipse">
+            <a:avLst/>
+          </a:prstGeom>
+          <a:solidFill>
+            <a:srgbClr val="171B20"/>
+          </a:solidFill>
+          <a:ln w="9525">
+            <a:solidFill>
+              <a:srgbClr val="2A3139"/>
+            </a:solidFill>
+            <a:prstDash val="solid"/>
+          </a:ln>
+        </p:spPr>
+      </p:sp>
+      <p:sp>
+        <p:nvSpPr>
+          <p:cNvPr id="6" name="Text 4"/>
+          <p:cNvSpPr txBox="1"/>
+          <p:nvPr/>
+        </p:nvSpPr>
+        <p:spPr>
+          <a:xfrm>
+            <a:off x="7223760" y="329184"/>
+            <a:ext cx="329184" cy="329184"/>
+          </a:xfrm>
+          <a:prstGeom prst="rect">
+            <a:avLst/>
+          </a:prstGeom>
+          <a:noFill/>
+          <a:ln/>
+        </p:spPr>
+        <p:txBody>
+          <a:bodyPr wrap="square" lIns="0" tIns="0" rIns="0" bIns="0" rtlCol="0" anchor="ctr"/>
+          <a:lstStyle/>
+          <a:p>
+            <a:pPr algn="ctr" indent="0" marL="0">
+              <a:buNone/>
+            </a:pPr>
+            <a:r>
+              <a:rPr lang="en-US" sz="900" b="1" dirty="0">
+                <a:solidFill>
+                  <a:srgbClr val="8E98A3"/>
+                </a:solidFill>
+                <a:latin typeface="Segoe UI" pitchFamily="34" charset="0"/>
+                <a:ea typeface="Segoe UI" pitchFamily="34" charset="-122"/>
+                <a:cs typeface="Segoe UI" pitchFamily="34" charset="-120"/>
+              </a:rPr>
+              <a:t>30</a:t>
+            </a:r>
+            <a:endParaRPr lang="en-US" sz="900" dirty="0"/>
+          </a:p>
+        </p:txBody>
+      </p:sp>
+      <p:sp>
+        <p:nvSpPr>
+          <p:cNvPr id="7" name="Shape 5"/>
+          <p:cNvSpPr/>
+          <p:nvPr/>
+        </p:nvSpPr>
+        <p:spPr>
+          <a:xfrm>
+            <a:off x="7662672" y="329184"/>
+            <a:ext cx="329184" cy="329184"/>
+          </a:xfrm>
+          <a:prstGeom prst="ellipse">
+            <a:avLst/>
+          </a:prstGeom>
+          <a:solidFill>
+            <a:srgbClr val="171B20"/>
+          </a:solidFill>
+          <a:ln w="9525">
+            <a:solidFill>
+              <a:srgbClr val="2A3139"/>
+            </a:solidFill>
+            <a:prstDash val="solid"/>
+          </a:ln>
+        </p:spPr>
+      </p:sp>
+      <p:sp>
+        <p:nvSpPr>
+          <p:cNvPr id="8" name="Text 6"/>
+          <p:cNvSpPr txBox="1"/>
+          <p:nvPr/>
+        </p:nvSpPr>
+        <p:spPr>
+          <a:xfrm>
+            <a:off x="7662672" y="329184"/>
+            <a:ext cx="329184" cy="329184"/>
+          </a:xfrm>
+          <a:prstGeom prst="rect">
+            <a:avLst/>
+          </a:prstGeom>
+          <a:noFill/>
+          <a:ln/>
+        </p:spPr>
+        <p:txBody>
+          <a:bodyPr wrap="square" lIns="0" tIns="0" rIns="0" bIns="0" rtlCol="0" anchor="ctr"/>
+          <a:lstStyle/>
+          <a:p>
+            <a:pPr algn="ctr" indent="0" marL="0">
+              <a:buNone/>
+            </a:pPr>
+            <a:r>
+              <a:rPr lang="en-US" sz="900" b="1" dirty="0">
+                <a:solidFill>
+                  <a:srgbClr val="8E98A3"/>
+                </a:solidFill>
+                <a:latin typeface="Segoe UI" pitchFamily="34" charset="0"/>
+                <a:ea typeface="Segoe UI" pitchFamily="34" charset="-122"/>
+                <a:cs typeface="Segoe UI" pitchFamily="34" charset="-120"/>
+              </a:rPr>
+              <a:t>60</a:t>
+            </a:r>
+            <a:endParaRPr lang="en-US" sz="900" dirty="0"/>
+          </a:p>
+        </p:txBody>
+      </p:sp>
+      <p:sp>
+        <p:nvSpPr>
+          <p:cNvPr id="9" name="Shape 7"/>
+          <p:cNvSpPr/>
+          <p:nvPr/>
+        </p:nvSpPr>
+        <p:spPr>
+          <a:xfrm>
+            <a:off x="8101584" y="329184"/>
+            <a:ext cx="329184" cy="329184"/>
+          </a:xfrm>
+          <a:prstGeom prst="ellipse">
+            <a:avLst/>
+          </a:prstGeom>
+          <a:solidFill>
+            <a:srgbClr val="F05A55"/>
+          </a:solidFill>
+          <a:ln w="9525">
+            <a:solidFill>
+              <a:srgbClr val="F05A55"/>
+            </a:solidFill>
+            <a:prstDash val="solid"/>
+          </a:ln>
+        </p:spPr>
+      </p:sp>
+      <p:sp>
+        <p:nvSpPr>
+          <p:cNvPr id="10" name="Text 8"/>
+          <p:cNvSpPr txBox="1"/>
+          <p:nvPr/>
+        </p:nvSpPr>
+        <p:spPr>
+          <a:xfrm>
+            <a:off x="8101584" y="329184"/>
+            <a:ext cx="329184" cy="329184"/>
+          </a:xfrm>
+          <a:prstGeom prst="rect">
+            <a:avLst/>
+          </a:prstGeom>
+          <a:noFill/>
+          <a:ln/>
+        </p:spPr>
+        <p:txBody>
+          <a:bodyPr wrap="square" lIns="0" tIns="0" rIns="0" bIns="0" rtlCol="0" anchor="ctr"/>
+          <a:lstStyle/>
+          <a:p>
+            <a:pPr algn="ctr" indent="0" marL="0">
+              <a:buNone/>
+            </a:pPr>
+            <a:r>
+              <a:rPr lang="en-US" sz="900" b="1" dirty="0">
+                <a:solidFill>
+                  <a:srgbClr val="0B0D10"/>
+                </a:solidFill>
+                <a:latin typeface="Segoe UI" pitchFamily="34" charset="0"/>
+                <a:ea typeface="Segoe UI" pitchFamily="34" charset="-122"/>
+                <a:cs typeface="Segoe UI" pitchFamily="34" charset="-120"/>
+              </a:rPr>
+              <a:t>90</a:t>
+            </a:r>
+            <a:endParaRPr lang="en-US" sz="900" dirty="0"/>
+          </a:p>
+        </p:txBody>
+      </p:sp>
+      <p:sp>
+        <p:nvSpPr>
+          <p:cNvPr id="11" name="Shape 9"/>
+          <p:cNvSpPr/>
+          <p:nvPr/>
+        </p:nvSpPr>
+        <p:spPr>
+          <a:xfrm>
+            <a:off x="640080" y="1371600"/>
+            <a:ext cx="3794760" cy="2240280"/>
+          </a:xfrm>
+          <a:prstGeom prst="rect">
+            <a:avLst/>
+          </a:prstGeom>
+          <a:solidFill>
+            <a:srgbClr val="171B20"/>
+          </a:solidFill>
+          <a:ln w="9525">
+            <a:solidFill>
+              <a:srgbClr val="2A3139"/>
+            </a:solidFill>
+            <a:prstDash val="solid"/>
+          </a:ln>
+        </p:spPr>
+      </p:sp>
+      <p:sp>
+        <p:nvSpPr>
+          <p:cNvPr id="12" name="Text 10"/>
+          <p:cNvSpPr txBox="1"/>
+          <p:nvPr/>
+        </p:nvSpPr>
+        <p:spPr>
+          <a:xfrm>
+            <a:off x="868680" y="1508760"/>
+            <a:ext cx="3383280" cy="256032"/>
+          </a:xfrm>
+          <a:prstGeom prst="rect">
+            <a:avLst/>
+          </a:prstGeom>
+          <a:noFill/>
+          <a:ln/>
+        </p:spPr>
+        <p:txBody>
+          <a:bodyPr wrap="square" lIns="0" tIns="0" rIns="0" bIns="0" rtlCol="0" anchor="ctr"/>
+          <a:lstStyle/>
+          <a:p>
+            <a:pPr indent="0" marL="0">
+              <a:buNone/>
+            </a:pPr>
+            <a:r>
+              <a:rPr lang="en-US" sz="950" dirty="0">
+                <a:solidFill>
+                  <a:srgbClr val="F05A55"/>
+                </a:solidFill>
+                <a:latin typeface="Consolas" pitchFamily="34" charset="0"/>
+                <a:ea typeface="Consolas" pitchFamily="34" charset="-122"/>
+                <a:cs typeface="Consolas" pitchFamily="34" charset="-120"/>
+              </a:rPr>
+              <a:t>EXISTING BUSINESS</a:t>
+            </a:r>
+            <a:endParaRPr lang="en-US" sz="950" dirty="0"/>
+          </a:p>
+        </p:txBody>
+      </p:sp>
+      <p:sp>
+        <p:nvSpPr>
+          <p:cNvPr id="13" name="Text 11"/>
+          <p:cNvSpPr txBox="1"/>
+          <p:nvPr/>
+        </p:nvSpPr>
+        <p:spPr>
+          <a:xfrm>
+            <a:off x="868680" y="1847088"/>
+            <a:ext cx="3383280" cy="1645920"/>
+          </a:xfrm>
+          <a:prstGeom prst="rect">
+            <a:avLst/>
+          </a:prstGeom>
+          <a:noFill/>
+          <a:ln/>
+        </p:spPr>
+        <p:txBody>
+          <a:bodyPr wrap="square" lIns="0" tIns="0" rIns="0" bIns="0" rtlCol="0" anchor="t"/>
+          <a:lstStyle/>
+          <a:p>
+            <a:pPr marL="342900" indent="-342900">
+              <a:spcAft>
+                <a:spcPts val="700"/>
+              </a:spcAft>
+              <a:buSzPct val="100000"/>
+              <a:buChar char="•"/>
+            </a:pPr>
+            <a:r>
+              <a:rPr lang="en-US" sz="1200" dirty="0">
+                <a:solidFill>
+                  <a:srgbClr val="C9CED4"/>
+                </a:solidFill>
+                <a:latin typeface="Segoe UI" pitchFamily="34" charset="0"/>
+                <a:ea typeface="Segoe UI" pitchFamily="34" charset="-122"/>
+                <a:cs typeface="Segoe UI" pitchFamily="34" charset="-120"/>
+              </a:rPr>
+              <a:t>Close expansion orders where the customer's timing allows</a:t>
+            </a:r>
+            <a:endParaRPr lang="en-US" sz="1200" dirty="0"/>
+          </a:p>
+          <a:p>
+            <a:pPr marL="342900" indent="-342900">
+              <a:spcAft>
+                <a:spcPts val="700"/>
+              </a:spcAft>
+              <a:buSzPct val="100000"/>
+              <a:buChar char="•"/>
+            </a:pPr>
+            <a:r>
+              <a:rPr lang="en-US" sz="1200" dirty="0">
+                <a:solidFill>
+                  <a:srgbClr val="C9CED4"/>
+                </a:solidFill>
+                <a:latin typeface="Segoe UI" pitchFamily="34" charset="0"/>
+                <a:ea typeface="Segoe UI" pitchFamily="34" charset="-122"/>
+                <a:cs typeface="Segoe UI" pitchFamily="34" charset="-120"/>
+              </a:rPr>
+              <a:t>Renewals and repeat orders secured and forecast</a:t>
+            </a:r>
+            <a:endParaRPr lang="en-US" sz="1200" dirty="0"/>
+          </a:p>
+          <a:p>
+            <a:pPr marL="342900" indent="-342900">
+              <a:spcAft>
+                <a:spcPts val="700"/>
+              </a:spcAft>
+              <a:buSzPct val="100000"/>
+              <a:buChar char="•"/>
+            </a:pPr>
+            <a:r>
+              <a:rPr lang="en-US" sz="1200" dirty="0">
+                <a:solidFill>
+                  <a:srgbClr val="C9CED4"/>
+                </a:solidFill>
+                <a:latin typeface="Segoe UI" pitchFamily="34" charset="0"/>
+                <a:ea typeface="Segoe UI" pitchFamily="34" charset="-122"/>
+                <a:cs typeface="Segoe UI" pitchFamily="34" charset="-120"/>
+              </a:rPr>
+              <a:t>Account plans for the top accounts, reviewed with Andy</a:t>
+            </a:r>
+            <a:endParaRPr lang="en-US" sz="1200" dirty="0"/>
+          </a:p>
+        </p:txBody>
+      </p:sp>
+      <p:sp>
+        <p:nvSpPr>
+          <p:cNvPr id="14" name="Shape 12"/>
+          <p:cNvSpPr/>
+          <p:nvPr/>
+        </p:nvSpPr>
+        <p:spPr>
+          <a:xfrm>
+            <a:off x="4709160" y="1371600"/>
+            <a:ext cx="3794760" cy="2240280"/>
+          </a:xfrm>
+          <a:prstGeom prst="rect">
+            <a:avLst/>
+          </a:prstGeom>
+          <a:solidFill>
+            <a:srgbClr val="171B20"/>
+          </a:solidFill>
+          <a:ln w="9525">
+            <a:solidFill>
+              <a:srgbClr val="2A3139"/>
+            </a:solidFill>
+            <a:prstDash val="solid"/>
+          </a:ln>
+        </p:spPr>
+      </p:sp>
+      <p:sp>
+        <p:nvSpPr>
+          <p:cNvPr id="15" name="Text 13"/>
+          <p:cNvSpPr txBox="1"/>
+          <p:nvPr/>
+        </p:nvSpPr>
+        <p:spPr>
+          <a:xfrm>
+            <a:off x="4937760" y="1508760"/>
+            <a:ext cx="3383280" cy="256032"/>
+          </a:xfrm>
+          <a:prstGeom prst="rect">
+            <a:avLst/>
+          </a:prstGeom>
+          <a:noFill/>
+          <a:ln/>
+        </p:spPr>
+        <p:txBody>
+          <a:bodyPr wrap="square" lIns="0" tIns="0" rIns="0" bIns="0" rtlCol="0" anchor="ctr"/>
+          <a:lstStyle/>
+          <a:p>
+            <a:pPr indent="0" marL="0">
+              <a:buNone/>
+            </a:pPr>
+            <a:r>
+              <a:rPr lang="en-US" sz="950" dirty="0">
+                <a:solidFill>
+                  <a:srgbClr val="F05A55"/>
+                </a:solidFill>
+                <a:latin typeface="Consolas" pitchFamily="34" charset="0"/>
+                <a:ea typeface="Consolas" pitchFamily="34" charset="-122"/>
+                <a:cs typeface="Consolas" pitchFamily="34" charset="-120"/>
+              </a:rPr>
+              <a:t>NEW BUSINESS</a:t>
+            </a:r>
+            <a:endParaRPr lang="en-US" sz="950" dirty="0"/>
+          </a:p>
+        </p:txBody>
+      </p:sp>
+      <p:sp>
+        <p:nvSpPr>
+          <p:cNvPr id="16" name="Text 14"/>
+          <p:cNvSpPr txBox="1"/>
+          <p:nvPr/>
+        </p:nvSpPr>
+        <p:spPr>
+          <a:xfrm>
+            <a:off x="4937760" y="1847088"/>
+            <a:ext cx="3383280" cy="1645920"/>
+          </a:xfrm>
+          <a:prstGeom prst="rect">
+            <a:avLst/>
+          </a:prstGeom>
+          <a:noFill/>
+          <a:ln/>
+        </p:spPr>
+        <p:txBody>
+          <a:bodyPr wrap="square" lIns="0" tIns="0" rIns="0" bIns="0" rtlCol="0" anchor="t"/>
+          <a:lstStyle/>
+          <a:p>
+            <a:pPr marL="342900" indent="-342900">
+              <a:spcAft>
+                <a:spcPts val="700"/>
+              </a:spcAft>
+              <a:buSzPct val="100000"/>
+              <a:buChar char="•"/>
+            </a:pPr>
+            <a:r>
+              <a:rPr lang="en-US" sz="1200" dirty="0">
+                <a:solidFill>
+                  <a:srgbClr val="C9CED4"/>
+                </a:solidFill>
+                <a:latin typeface="Segoe UI" pitchFamily="34" charset="0"/>
+                <a:ea typeface="Segoe UI" pitchFamily="34" charset="-122"/>
+                <a:cs typeface="Segoe UI" pitchFamily="34" charset="-120"/>
+              </a:rPr>
+              <a:t>Design-in decisions where the customer's clock allows</a:t>
+            </a:r>
+            <a:endParaRPr lang="en-US" sz="1200" dirty="0"/>
+          </a:p>
+          <a:p>
+            <a:pPr marL="342900" indent="-342900">
+              <a:spcAft>
+                <a:spcPts val="700"/>
+              </a:spcAft>
+              <a:buSzPct val="100000"/>
+              <a:buChar char="•"/>
+            </a:pPr>
+            <a:r>
+              <a:rPr lang="en-US" sz="1200" dirty="0">
+                <a:solidFill>
+                  <a:srgbClr val="C9CED4"/>
+                </a:solidFill>
+                <a:latin typeface="Segoe UI" pitchFamily="34" charset="0"/>
+                <a:ea typeface="Segoe UI" pitchFamily="34" charset="-122"/>
+                <a:cs typeface="Segoe UI" pitchFamily="34" charset="-120"/>
+              </a:rPr>
+              <a:t>Every target account: advance, nurture or stop, with a reason</a:t>
+            </a:r>
+            <a:endParaRPr lang="en-US" sz="1200" dirty="0"/>
+          </a:p>
+          <a:p>
+            <a:pPr marL="342900" indent="-342900">
+              <a:spcAft>
+                <a:spcPts val="700"/>
+              </a:spcAft>
+              <a:buSzPct val="100000"/>
+              <a:buChar char="•"/>
+            </a:pPr>
+            <a:r>
+              <a:rPr lang="en-US" sz="1200" dirty="0">
+                <a:solidFill>
+                  <a:srgbClr val="C9CED4"/>
+                </a:solidFill>
+                <a:latin typeface="Segoe UI" pitchFamily="34" charset="0"/>
+                <a:ea typeface="Segoe UI" pitchFamily="34" charset="-122"/>
+                <a:cs typeface="Segoe UI" pitchFamily="34" charset="-120"/>
+              </a:rPr>
+              <a:t>Partner pilots: expand, revise or end</a:t>
+            </a:r>
+            <a:endParaRPr lang="en-US" sz="1200" dirty="0"/>
+          </a:p>
+        </p:txBody>
+      </p:sp>
+      <p:sp>
+        <p:nvSpPr>
+          <p:cNvPr id="17" name="Shape 15"/>
+          <p:cNvSpPr/>
+          <p:nvPr/>
+        </p:nvSpPr>
+        <p:spPr>
+          <a:xfrm>
+            <a:off x="640080" y="3749040"/>
+            <a:ext cx="7863840" cy="658368"/>
+          </a:xfrm>
+          <a:prstGeom prst="rect">
+            <a:avLst/>
+          </a:prstGeom>
+          <a:solidFill>
+            <a:srgbClr val="3A1F21"/>
+          </a:solidFill>
+          <a:ln w="9525">
+            <a:solidFill>
+              <a:srgbClr val="F05A55"/>
+            </a:solidFill>
+            <a:prstDash val="solid"/>
+          </a:ln>
+        </p:spPr>
+      </p:sp>
+      <p:sp>
+        <p:nvSpPr>
+          <p:cNvPr id="18" name="Text 16"/>
+          <p:cNvSpPr txBox="1"/>
+          <p:nvPr/>
+        </p:nvSpPr>
+        <p:spPr>
+          <a:xfrm>
+            <a:off x="868680" y="3785616"/>
+            <a:ext cx="4480560" cy="585216"/>
+          </a:xfrm>
+          <a:prstGeom prst="rect">
+            <a:avLst/>
+          </a:prstGeom>
+          <a:noFill/>
+          <a:ln/>
+        </p:spPr>
+        <p:txBody>
+          <a:bodyPr wrap="square" lIns="0" tIns="0" rIns="0" bIns="0" rtlCol="0" anchor="ctr"/>
+          <a:lstStyle/>
+          <a:p>
+            <a:pPr indent="0" marL="0">
+              <a:buNone/>
+            </a:pPr>
+            <a:r>
+              <a:rPr lang="en-US" sz="950" dirty="0">
+                <a:solidFill>
+                  <a:srgbClr val="F05A55"/>
+                </a:solidFill>
+                <a:latin typeface="Consolas" pitchFamily="34" charset="0"/>
+                <a:ea typeface="Consolas" pitchFamily="34" charset="-122"/>
+                <a:cs typeface="Consolas" pitchFamily="34" charset="-120"/>
+              </a:rPr>
+              <a:t>GATE   </a:t>
+            </a:r>
+            <a:pPr indent="0" marL="0">
+              <a:buNone/>
+            </a:pPr>
+            <a:r>
+              <a:rPr lang="en-US" sz="1200" b="1" dirty="0">
+                <a:solidFill>
+                  <a:srgbClr val="F2F4F6"/>
+                </a:solidFill>
+                <a:latin typeface="Segoe UI" pitchFamily="34" charset="0"/>
+                <a:ea typeface="Segoe UI" pitchFamily="34" charset="-122"/>
+                <a:cs typeface="Segoe UI" pitchFamily="34" charset="-120"/>
+              </a:rPr>
+              <a:t>Customer-backed forecast and a territory recommendation</a:t>
+            </a:r>
+            <a:endParaRPr lang="en-US" sz="1200" dirty="0"/>
+          </a:p>
+        </p:txBody>
+      </p:sp>
+      <p:sp>
+        <p:nvSpPr>
+          <p:cNvPr id="19" name="Text 17"/>
+          <p:cNvSpPr txBox="1"/>
+          <p:nvPr/>
+        </p:nvSpPr>
+        <p:spPr>
+          <a:xfrm>
+            <a:off x="5394960" y="3785616"/>
+            <a:ext cx="2971800" cy="585216"/>
+          </a:xfrm>
+          <a:prstGeom prst="rect">
+            <a:avLst/>
+          </a:prstGeom>
+          <a:noFill/>
+          <a:ln/>
+        </p:spPr>
+        <p:txBody>
+          <a:bodyPr wrap="square" lIns="0" tIns="0" rIns="0" bIns="0" rtlCol="0" anchor="ctr"/>
+          <a:lstStyle/>
+          <a:p>
+            <a:pPr indent="0" marL="0">
+              <a:buNone/>
+            </a:pPr>
+            <a:r>
+              <a:rPr lang="en-US" sz="900" dirty="0">
+                <a:solidFill>
+                  <a:srgbClr val="8E98A3"/>
+                </a:solidFill>
+                <a:latin typeface="Consolas" pitchFamily="34" charset="0"/>
+                <a:ea typeface="Consolas" pitchFamily="34" charset="-122"/>
+                <a:cs typeface="Consolas" pitchFamily="34" charset="-120"/>
+              </a:rPr>
+              <a:t>MEASURED BY   </a:t>
+            </a:r>
+            <a:pPr indent="0" marL="0">
+              <a:buNone/>
+            </a:pPr>
+            <a:r>
+              <a:rPr lang="en-US" sz="1050" dirty="0">
+                <a:solidFill>
+                  <a:srgbClr val="C9CED4"/>
+                </a:solidFill>
+                <a:latin typeface="Segoe UI" pitchFamily="34" charset="0"/>
+                <a:ea typeface="Segoe UI" pitchFamily="34" charset="-122"/>
+                <a:cs typeface="Segoe UI" pitchFamily="34" charset="-120"/>
+              </a:rPr>
+              <a:t>20 documented account decisions · every forecast input labelled</a:t>
+            </a:r>
+            <a:endParaRPr lang="en-US" sz="1050" dirty="0"/>
+          </a:p>
+        </p:txBody>
+      </p:sp>
+    </p:spTree>
+  </p:cSld>
+  <p:clrMapOvr>
+    <a:masterClrMapping/>
+  </p:clrMapOvr>
+</p:sld>
+</file>
+
+<file path=ppt/slides/slide13.xml><?xml version="1.0" encoding="utf-8"?>
+<p:sld xmlns:a="http://schemas.openxmlformats.org/drawingml/2006/main" xmlns:r="http://schemas.openxmlformats.org/officeDocument/2006/relationships" xmlns:p="http://schemas.openxmlformats.org/presentationml/2006/main">
+  <p:cSld name="Slide 13">
+    <p:bg>
+      <p:bgPr>
+        <a:solidFill>
+          <a:srgbClr val="0B0D10"/>
+        </a:solidFill>
+      </p:bgPr>
+    </p:bg>
+    <p:spTree>
+      <p:nvGrpSpPr>
+        <p:cNvPr id="1" name=""/>
+        <p:cNvGrpSpPr/>
+        <p:nvPr/>
+      </p:nvGrpSpPr>
+      <p:grpSpPr>
+        <a:xfrm>
+          <a:off x="0" y="0"/>
+          <a:ext cx="0" cy="0"/>
+          <a:chOff x="0" y="0"/>
+          <a:chExt cx="0" cy="0"/>
+        </a:xfrm>
+      </p:grpSpPr>
+      <p:sp>
+        <p:nvSpPr>
+          <p:cNvPr id="2" name="Text 0"/>
+          <p:cNvSpPr txBox="1"/>
+          <p:nvPr/>
+        </p:nvSpPr>
+        <p:spPr>
+          <a:xfrm>
+            <a:off x="640080" y="384048"/>
+            <a:ext cx="7863840" cy="228600"/>
+          </a:xfrm>
+          <a:prstGeom prst="rect">
+            <a:avLst/>
+          </a:prstGeom>
+          <a:noFill/>
+          <a:ln/>
+        </p:spPr>
+        <p:txBody>
+          <a:bodyPr wrap="square" lIns="0" tIns="0" rIns="0" bIns="0" rtlCol="0" anchor="ctr"/>
+          <a:lstStyle/>
+          <a:p>
+            <a:pPr indent="0" marL="0">
+              <a:buNone/>
+            </a:pPr>
+            <a:r>
+              <a:rPr lang="en-US" sz="950" spc="100" kern="0" dirty="0">
+                <a:solidFill>
+                  <a:srgbClr val="8E98A3"/>
+                </a:solidFill>
+                <a:latin typeface="Consolas" pitchFamily="34" charset="0"/>
+                <a:ea typeface="Consolas" pitchFamily="34" charset="-122"/>
+                <a:cs typeface="Consolas" pitchFamily="34" charset="-120"/>
+              </a:rPr>
+              <a:t>DISCUSSION</a:t>
+            </a:r>
+            <a:endParaRPr lang="en-US" sz="950" dirty="0"/>
+          </a:p>
+        </p:txBody>
+      </p:sp>
+      <p:sp>
+        <p:nvSpPr>
+          <p:cNvPr id="3" name="Text 1"/>
+          <p:cNvSpPr txBox="1"/>
+          <p:nvPr/>
+        </p:nvSpPr>
+        <p:spPr>
+          <a:xfrm>
+            <a:off x="640080" y="658368"/>
+            <a:ext cx="7863840" cy="566928"/>
+          </a:xfrm>
+          <a:prstGeom prst="rect">
+            <a:avLst/>
+          </a:prstGeom>
+          <a:noFill/>
+          <a:ln/>
+        </p:spPr>
+        <p:txBody>
+          <a:bodyPr wrap="square" lIns="0" tIns="0" rIns="0" bIns="0" rtlCol="0" anchor="t"/>
+          <a:lstStyle/>
+          <a:p>
+            <a:pPr indent="0" marL="0">
+              <a:buNone/>
+            </a:pPr>
+            <a:r>
+              <a:rPr lang="en-US" sz="2200" b="1" dirty="0">
+                <a:solidFill>
+                  <a:srgbClr val="F2F4F6"/>
+                </a:solidFill>
+                <a:latin typeface="Segoe UI" pitchFamily="34" charset="0"/>
+                <a:ea typeface="Segoe UI" pitchFamily="34" charset="-122"/>
+                <a:cs typeface="Segoe UI" pitchFamily="34" charset="-120"/>
+              </a:rPr>
+              <a:t>Three questions for you</a:t>
+            </a:r>
+            <a:endParaRPr lang="en-US" sz="2200" dirty="0"/>
+          </a:p>
+        </p:txBody>
+      </p:sp>
+      <p:sp>
+        <p:nvSpPr>
+          <p:cNvPr id="4" name="Text 2"/>
+          <p:cNvSpPr txBox="1"/>
+          <p:nvPr/>
+        </p:nvSpPr>
+        <p:spPr>
+          <a:xfrm>
+            <a:off x="640080" y="1371600"/>
+            <a:ext cx="1463040" cy="685800"/>
+          </a:xfrm>
+          <a:prstGeom prst="rect">
+            <a:avLst/>
+          </a:prstGeom>
+          <a:noFill/>
+          <a:ln/>
+        </p:spPr>
+        <p:txBody>
+          <a:bodyPr wrap="square" lIns="0" tIns="0" rIns="0" bIns="0" rtlCol="0" anchor="t"/>
+          <a:lstStyle/>
+          <a:p>
+            <a:pPr indent="0" marL="0">
+              <a:buNone/>
+            </a:pPr>
+            <a:r>
+              <a:rPr lang="en-US" sz="1000" dirty="0">
+                <a:solidFill>
+                  <a:srgbClr val="F05A55"/>
+                </a:solidFill>
+                <a:latin typeface="Consolas" pitchFamily="34" charset="0"/>
+                <a:ea typeface="Consolas" pitchFamily="34" charset="-122"/>
+                <a:cs typeface="Consolas" pitchFamily="34" charset="-120"/>
+              </a:rPr>
+              <a:t>GROWTH</a:t>
+            </a:r>
+            <a:endParaRPr lang="en-US" sz="1000" dirty="0"/>
+          </a:p>
+        </p:txBody>
+      </p:sp>
+      <p:sp>
+        <p:nvSpPr>
+          <p:cNvPr id="5" name="Text 3"/>
+          <p:cNvSpPr txBox="1"/>
+          <p:nvPr/>
+        </p:nvSpPr>
+        <p:spPr>
+          <a:xfrm>
+            <a:off x="2194560" y="1371600"/>
+            <a:ext cx="6309360" cy="685800"/>
+          </a:xfrm>
+          <a:prstGeom prst="rect">
+            <a:avLst/>
+          </a:prstGeom>
+          <a:noFill/>
+          <a:ln/>
+        </p:spPr>
+        <p:txBody>
+          <a:bodyPr wrap="square" lIns="0" tIns="0" rIns="0" bIns="0" rtlCol="0" anchor="t"/>
+          <a:lstStyle/>
+          <a:p>
+            <a:pPr indent="0" marL="0">
+              <a:buNone/>
+            </a:pPr>
+            <a:r>
+              <a:rPr lang="en-US" sz="1300" dirty="0">
+                <a:solidFill>
+                  <a:srgbClr val="F2F4F6"/>
+                </a:solidFill>
+                <a:latin typeface="Segoe UI" pitchFamily="34" charset="0"/>
+                <a:ea typeface="Segoe UI" pitchFamily="34" charset="-122"/>
+                <a:cs typeface="Segoe UI" pitchFamily="34" charset="-120"/>
+              </a:rPr>
+              <a:t>Is Europe mainly a new-logo build, expansion inside platforms you're already on, or a real step-up in regional revenue?</a:t>
+            </a:r>
+            <a:endParaRPr lang="en-US" sz="1300" dirty="0"/>
+          </a:p>
+        </p:txBody>
+      </p:sp>
+      <p:sp>
+        <p:nvSpPr>
+          <p:cNvPr id="6" name="Text 4"/>
+          <p:cNvSpPr txBox="1"/>
+          <p:nvPr/>
+        </p:nvSpPr>
+        <p:spPr>
+          <a:xfrm>
+            <a:off x="640080" y="2240280"/>
+            <a:ext cx="1463040" cy="685800"/>
+          </a:xfrm>
+          <a:prstGeom prst="rect">
+            <a:avLst/>
+          </a:prstGeom>
+          <a:noFill/>
+          <a:ln/>
+        </p:spPr>
+        <p:txBody>
+          <a:bodyPr wrap="square" lIns="0" tIns="0" rIns="0" bIns="0" rtlCol="0" anchor="t"/>
+          <a:lstStyle/>
+          <a:p>
+            <a:pPr indent="0" marL="0">
+              <a:buNone/>
+            </a:pPr>
+            <a:r>
+              <a:rPr lang="en-US" sz="1000" dirty="0">
+                <a:solidFill>
+                  <a:srgbClr val="F05A55"/>
+                </a:solidFill>
+                <a:latin typeface="Consolas" pitchFamily="34" charset="0"/>
+                <a:ea typeface="Consolas" pitchFamily="34" charset="-122"/>
+                <a:cs typeface="Consolas" pitchFamily="34" charset="-120"/>
+              </a:rPr>
+              <a:t>OWNERSHIP</a:t>
+            </a:r>
+            <a:endParaRPr lang="en-US" sz="1000" dirty="0"/>
+          </a:p>
+        </p:txBody>
+      </p:sp>
+      <p:sp>
+        <p:nvSpPr>
+          <p:cNvPr id="7" name="Text 5"/>
+          <p:cNvSpPr txBox="1"/>
+          <p:nvPr/>
+        </p:nvSpPr>
+        <p:spPr>
+          <a:xfrm>
+            <a:off x="2194560" y="2240280"/>
+            <a:ext cx="6309360" cy="685800"/>
+          </a:xfrm>
+          <a:prstGeom prst="rect">
+            <a:avLst/>
+          </a:prstGeom>
+          <a:noFill/>
+          <a:ln/>
+        </p:spPr>
+        <p:txBody>
+          <a:bodyPr wrap="square" lIns="0" tIns="0" rIns="0" bIns="0" rtlCol="0" anchor="t"/>
+          <a:lstStyle/>
+          <a:p>
+            <a:pPr indent="0" marL="0">
+              <a:buNone/>
+            </a:pPr>
+            <a:r>
+              <a:rPr lang="en-US" sz="1300" dirty="0">
+                <a:solidFill>
+                  <a:srgbClr val="F2F4F6"/>
+                </a:solidFill>
+                <a:latin typeface="Segoe UI" pitchFamily="34" charset="0"/>
+                <a:ea typeface="Segoe UI" pitchFamily="34" charset="-122"/>
+                <a:cs typeface="Segoe UI" pitchFamily="34" charset="-120"/>
+              </a:rPr>
+              <a:t>When a high-value OEM sits across a border, does ownership follow geography, relationships, or whoever is best placed to win the design-in?</a:t>
+            </a:r>
+            <a:endParaRPr lang="en-US" sz="1300" dirty="0"/>
+          </a:p>
+        </p:txBody>
+      </p:sp>
+      <p:sp>
+        <p:nvSpPr>
+          <p:cNvPr id="8" name="Text 6"/>
+          <p:cNvSpPr txBox="1"/>
+          <p:nvPr/>
+        </p:nvSpPr>
+        <p:spPr>
+          <a:xfrm>
+            <a:off x="640080" y="3108960"/>
+            <a:ext cx="1463040" cy="685800"/>
+          </a:xfrm>
+          <a:prstGeom prst="rect">
+            <a:avLst/>
+          </a:prstGeom>
+          <a:noFill/>
+          <a:ln/>
+        </p:spPr>
+        <p:txBody>
+          <a:bodyPr wrap="square" lIns="0" tIns="0" rIns="0" bIns="0" rtlCol="0" anchor="t"/>
+          <a:lstStyle/>
+          <a:p>
+            <a:pPr indent="0" marL="0">
+              <a:buNone/>
+            </a:pPr>
+            <a:r>
+              <a:rPr lang="en-US" sz="1000" dirty="0">
+                <a:solidFill>
+                  <a:srgbClr val="F05A55"/>
+                </a:solidFill>
+                <a:latin typeface="Consolas" pitchFamily="34" charset="0"/>
+                <a:ea typeface="Consolas" pitchFamily="34" charset="-122"/>
+                <a:cs typeface="Consolas" pitchFamily="34" charset="-120"/>
+              </a:rPr>
+              <a:t>SUCCESS</a:t>
+            </a:r>
+            <a:endParaRPr lang="en-US" sz="1000" dirty="0"/>
+          </a:p>
+        </p:txBody>
+      </p:sp>
+      <p:sp>
+        <p:nvSpPr>
+          <p:cNvPr id="9" name="Text 7"/>
+          <p:cNvSpPr txBox="1"/>
+          <p:nvPr/>
+        </p:nvSpPr>
+        <p:spPr>
+          <a:xfrm>
+            <a:off x="2194560" y="3108960"/>
+            <a:ext cx="6309360" cy="685800"/>
+          </a:xfrm>
+          <a:prstGeom prst="rect">
+            <a:avLst/>
+          </a:prstGeom>
+          <a:noFill/>
+          <a:ln/>
+        </p:spPr>
+        <p:txBody>
+          <a:bodyPr wrap="square" lIns="0" tIns="0" rIns="0" bIns="0" rtlCol="0" anchor="t"/>
+          <a:lstStyle/>
+          <a:p>
+            <a:pPr indent="0" marL="0">
+              <a:buNone/>
+            </a:pPr>
+            <a:r>
+              <a:rPr lang="en-US" sz="1300" dirty="0">
+                <a:solidFill>
+                  <a:srgbClr val="F2F4F6"/>
+                </a:solidFill>
+                <a:latin typeface="Segoe UI" pitchFamily="34" charset="0"/>
+                <a:ea typeface="Segoe UI" pitchFamily="34" charset="-122"/>
+                <a:cs typeface="Segoe UI" pitchFamily="34" charset="-120"/>
+              </a:rPr>
+              <a:t>Twelve months from now, what would make you say this role clearly exceeded expectations?</a:t>
+            </a:r>
+            <a:endParaRPr lang="en-US" sz="1300" dirty="0"/>
+          </a:p>
+        </p:txBody>
+      </p:sp>
+    </p:spTree>
+  </p:cSld>
+  <p:clrMapOvr>
+    <a:masterClrMapping/>
+  </p:clrMapOvr>
+</p:sld>
+</file>
+
+<file path=ppt/slides/slide14.xml><?xml version="1.0" encoding="utf-8"?>
+<p:sld xmlns:a="http://schemas.openxmlformats.org/drawingml/2006/main" xmlns:r="http://schemas.openxmlformats.org/officeDocument/2006/relationships" xmlns:p="http://schemas.openxmlformats.org/presentationml/2006/main">
+  <p:cSld name="Slide 14">
+    <p:bg>
+      <p:bgPr>
+        <a:solidFill>
+          <a:srgbClr val="0B0D10"/>
+        </a:solidFill>
+      </p:bgPr>
+    </p:bg>
+    <p:spTree>
+      <p:nvGrpSpPr>
+        <p:cNvPr id="1" name=""/>
+        <p:cNvGrpSpPr/>
+        <p:nvPr/>
+      </p:nvGrpSpPr>
+      <p:grpSpPr>
+        <a:xfrm>
+          <a:off x="0" y="0"/>
+          <a:ext cx="0" cy="0"/>
+          <a:chOff x="0" y="0"/>
+          <a:chExt cx="0" cy="0"/>
+        </a:xfrm>
+      </p:grpSpPr>
+      <p:sp>
+        <p:nvSpPr>
+          <p:cNvPr id="2" name="Text 0"/>
+          <p:cNvSpPr txBox="1"/>
+          <p:nvPr/>
+        </p:nvSpPr>
+        <p:spPr>
+          <a:xfrm>
+            <a:off x="640080" y="384048"/>
+            <a:ext cx="7863840" cy="228600"/>
+          </a:xfrm>
+          <a:prstGeom prst="rect">
+            <a:avLst/>
+          </a:prstGeom>
+          <a:noFill/>
+          <a:ln/>
+        </p:spPr>
+        <p:txBody>
+          <a:bodyPr wrap="square" lIns="0" tIns="0" rIns="0" bIns="0" rtlCol="0" anchor="ctr"/>
+          <a:lstStyle/>
+          <a:p>
+            <a:pPr indent="0" marL="0">
+              <a:buNone/>
+            </a:pPr>
+            <a:r>
+              <a:rPr lang="en-US" sz="950" spc="100" kern="0" dirty="0">
+                <a:solidFill>
+                  <a:srgbClr val="8E98A3"/>
+                </a:solidFill>
+                <a:latin typeface="Consolas" pitchFamily="34" charset="0"/>
+                <a:ea typeface="Consolas" pitchFamily="34" charset="-122"/>
+                <a:cs typeface="Consolas" pitchFamily="34" charset="-120"/>
+              </a:rPr>
               <a:t>BACKUP · OPEN ONLY IF ASKED</a:t>
             </a:r>
             <a:endParaRPr lang="en-US" sz="950" dirty="0"/>
@@ -4446,45 +6029,6 @@
         </p:nvSpPr>
         <p:spPr>
           <a:xfrm>
-            <a:off x="640080" y="384048"/>
-            <a:ext cx="7863840" cy="228600"/>
-          </a:xfrm>
-          <a:prstGeom prst="rect">
-            <a:avLst/>
-          </a:prstGeom>
-          <a:noFill/>
-          <a:ln/>
-        </p:spPr>
-        <p:txBody>
-          <a:bodyPr wrap="square" lIns="0" tIns="0" rIns="0" bIns="0" rtlCol="0" anchor="ctr"/>
-          <a:lstStyle/>
-          <a:p>
-            <a:pPr indent="0" marL="0">
-              <a:buNone/>
-            </a:pPr>
-            <a:r>
-              <a:rPr lang="en-US" sz="950" spc="100" kern="0" dirty="0">
-                <a:solidFill>
-                  <a:srgbClr val="8E98A3"/>
-                </a:solidFill>
-                <a:latin typeface="Consolas" pitchFamily="34" charset="0"/>
-                <a:ea typeface="Consolas" pitchFamily="34" charset="-122"/>
-                <a:cs typeface="Consolas" pitchFamily="34" charset="-120"/>
-              </a:rPr>
-              <a:t>WHO IS PRESENTING</a:t>
-            </a:r>
-            <a:endParaRPr lang="en-US" sz="950" dirty="0"/>
-          </a:p>
-        </p:txBody>
-      </p:sp>
-      <p:sp>
-        <p:nvSpPr>
-          <p:cNvPr id="3" name="Text 1"/>
-          <p:cNvSpPr txBox="1"/>
-          <p:nvPr/>
-        </p:nvSpPr>
-        <p:spPr>
-          <a:xfrm>
             <a:off x="640080" y="658368"/>
             <a:ext cx="7863840" cy="566928"/>
           </a:xfrm>
@@ -4518,7 +6062,7 @@
       </p:sp>
       <p:sp>
         <p:nvSpPr>
-          <p:cNvPr id="4" name="Text 2"/>
+          <p:cNvPr id="3" name="Text 1"/>
           <p:cNvSpPr txBox="1"/>
           <p:nvPr/>
         </p:nvSpPr>
@@ -4549,7 +6093,7 @@
                 <a:ea typeface="Segoe UI" pitchFamily="34" charset="-122"/>
                 <a:cs typeface="Segoe UI" pitchFamily="34" charset="-120"/>
               </a:rPr>
-              <a:t>The gap, stated upfront: I have not sold a radio as the component vendor. I know the seat your customers sit in.</a:t>
+              <a:t>What I haven't done: sell a radio as the component vendor.</a:t>
             </a:r>
             <a:endParaRPr lang="en-US" sz="950" dirty="0"/>
           </a:p>
@@ -4557,7 +6101,7 @@
       </p:sp>
       <p:sp>
         <p:nvSpPr>
-          <p:cNvPr id="5" name="Text 3"/>
+          <p:cNvPr id="4" name="Text 2"/>
           <p:cNvSpPr txBox="1"/>
           <p:nvPr/>
         </p:nvSpPr>
@@ -4596,7 +6140,7 @@
       </p:sp>
       <p:sp>
         <p:nvSpPr>
-          <p:cNvPr id="6" name="Text 4"/>
+          <p:cNvPr id="5" name="Text 3"/>
           <p:cNvSpPr txBox="1"/>
           <p:nvPr/>
         </p:nvSpPr>
@@ -4635,7 +6179,7 @@
       </p:sp>
       <p:sp>
         <p:nvSpPr>
-          <p:cNvPr id="7" name="Text 5"/>
+          <p:cNvPr id="6" name="Text 4"/>
           <p:cNvSpPr txBox="1"/>
           <p:nvPr/>
         </p:nvSpPr>
@@ -4674,7 +6218,7 @@
       </p:sp>
       <p:sp>
         <p:nvSpPr>
-          <p:cNvPr id="8" name="Text 6"/>
+          <p:cNvPr id="7" name="Text 5"/>
           <p:cNvSpPr txBox="1"/>
           <p:nvPr/>
         </p:nvSpPr>
@@ -4713,7 +6257,7 @@
       </p:sp>
       <p:sp>
         <p:nvSpPr>
-          <p:cNvPr id="9" name="Text 7"/>
+          <p:cNvPr id="8" name="Text 6"/>
           <p:cNvSpPr txBox="1"/>
           <p:nvPr/>
         </p:nvSpPr>
@@ -4744,7 +6288,7 @@
                 <a:ea typeface="Segoe UI" pitchFamily="34" charset="-122"/>
                 <a:cs typeface="Segoe UI" pitchFamily="34" charset="-120"/>
               </a:rPr>
-              <a:t>90+</a:t>
+              <a:t>2 yrs</a:t>
             </a:r>
             <a:endParaRPr lang="en-US" sz="4000" dirty="0"/>
           </a:p>
@@ -4752,7 +6296,7 @@
       </p:sp>
       <p:sp>
         <p:nvSpPr>
-          <p:cNvPr id="10" name="Text 8"/>
+          <p:cNvPr id="9" name="Text 7"/>
           <p:cNvSpPr txBox="1"/>
           <p:nvPr/>
         </p:nvSpPr>
@@ -4783,7 +6327,7 @@
                 <a:ea typeface="Segoe UI" pitchFamily="34" charset="-122"/>
                 <a:cs typeface="Segoe UI" pitchFamily="34" charset="-120"/>
               </a:rPr>
-              <a:t>Distribution and integration partners built at an industrial UAV OEM, where I integrated third-party subsystems.</a:t>
+              <a:t>At an industrial UAV OEM, integrating third-party subsystems into our own platforms and selling the system.</a:t>
             </a:r>
             <a:endParaRPr lang="en-US" sz="1200" dirty="0"/>
           </a:p>
@@ -4907,45 +6451,6 @@
         </p:nvSpPr>
         <p:spPr>
           <a:xfrm>
-            <a:off x="640080" y="4590288"/>
-            <a:ext cx="7863840" cy="256032"/>
-          </a:xfrm>
-          <a:prstGeom prst="rect">
-            <a:avLst/>
-          </a:prstGeom>
-          <a:noFill/>
-          <a:ln/>
-        </p:spPr>
-        <p:txBody>
-          <a:bodyPr wrap="square" lIns="0" tIns="0" rIns="0" bIns="0" rtlCol="0" anchor="ctr"/>
-          <a:lstStyle/>
-          <a:p>
-            <a:pPr indent="0" marL="0">
-              <a:buNone/>
-            </a:pPr>
-            <a:r>
-              <a:rPr lang="en-US" sz="950" dirty="0">
-                <a:solidFill>
-                  <a:srgbClr val="F05A55"/>
-                </a:solidFill>
-                <a:latin typeface="Segoe UI" pitchFamily="34" charset="0"/>
-                <a:ea typeface="Segoe UI" pitchFamily="34" charset="-122"/>
-                <a:cs typeface="Segoe UI" pitchFamily="34" charset="-120"/>
-              </a:rPr>
-              <a:t>Budgets become platforms; every platform needs a link. I call the OEM, not the ministry.</a:t>
-            </a:r>
-            <a:endParaRPr lang="en-US" sz="950" dirty="0"/>
-          </a:p>
-        </p:txBody>
-      </p:sp>
-      <p:sp>
-        <p:nvSpPr>
-          <p:cNvPr id="5" name="Text 3"/>
-          <p:cNvSpPr txBox="1"/>
-          <p:nvPr/>
-        </p:nvSpPr>
-        <p:spPr>
-          <a:xfrm>
             <a:off x="640080" y="1600200"/>
             <a:ext cx="2377440" cy="685800"/>
           </a:xfrm>
@@ -4979,7 +6484,7 @@
       </p:sp>
       <p:sp>
         <p:nvSpPr>
-          <p:cNvPr id="6" name="Text 4"/>
+          <p:cNvPr id="5" name="Text 3"/>
           <p:cNvSpPr txBox="1"/>
           <p:nvPr/>
         </p:nvSpPr>
@@ -5018,7 +6523,7 @@
       </p:sp>
       <p:sp>
         <p:nvSpPr>
-          <p:cNvPr id="7" name="Text 5"/>
+          <p:cNvPr id="6" name="Text 4"/>
           <p:cNvSpPr txBox="1"/>
           <p:nvPr/>
         </p:nvSpPr>
@@ -5057,7 +6562,7 @@
       </p:sp>
       <p:sp>
         <p:nvSpPr>
-          <p:cNvPr id="8" name="Text 6"/>
+          <p:cNvPr id="7" name="Text 5"/>
           <p:cNvSpPr txBox="1"/>
           <p:nvPr/>
         </p:nvSpPr>
@@ -5096,7 +6601,7 @@
       </p:sp>
       <p:sp>
         <p:nvSpPr>
-          <p:cNvPr id="9" name="Text 7"/>
+          <p:cNvPr id="8" name="Text 6"/>
           <p:cNvSpPr txBox="1"/>
           <p:nvPr/>
         </p:nvSpPr>
@@ -5135,7 +6640,7 @@
       </p:sp>
       <p:sp>
         <p:nvSpPr>
-          <p:cNvPr id="10" name="Text 8"/>
+          <p:cNvPr id="9" name="Text 7"/>
           <p:cNvSpPr txBox="1"/>
           <p:nvPr/>
         </p:nvSpPr>
@@ -5167,45 +6672,6 @@
                 <a:cs typeface="Segoe UI" pitchFamily="34" charset="-120"/>
               </a:rPr>
               <a:t>EU defence projects approved 28 Sep 2026, including drones and counter-drone.</a:t>
-            </a:r>
-            <a:endParaRPr lang="en-US" sz="1200" dirty="0"/>
-          </a:p>
-        </p:txBody>
-      </p:sp>
-      <p:sp>
-        <p:nvSpPr>
-          <p:cNvPr id="11" name="Text 9"/>
-          <p:cNvSpPr txBox="1"/>
-          <p:nvPr/>
-        </p:nvSpPr>
-        <p:spPr>
-          <a:xfrm>
-            <a:off x="640080" y="3611880"/>
-            <a:ext cx="7863840" cy="365760"/>
-          </a:xfrm>
-          <a:prstGeom prst="rect">
-            <a:avLst/>
-          </a:prstGeom>
-          <a:noFill/>
-          <a:ln/>
-        </p:spPr>
-        <p:txBody>
-          <a:bodyPr wrap="square" lIns="0" tIns="0" rIns="0" bIns="0" rtlCol="0" anchor="ctr"/>
-          <a:lstStyle/>
-          <a:p>
-            <a:pPr indent="0" marL="0">
-              <a:buNone/>
-            </a:pPr>
-            <a:r>
-              <a:rPr lang="en-US" sz="1200" i="1" dirty="0">
-                <a:solidFill>
-                  <a:srgbClr val="8E98A3"/>
-                </a:solidFill>
-                <a:latin typeface="Segoe UI" pitchFamily="34" charset="0"/>
-                <a:ea typeface="Segoe UI" pitchFamily="34" charset="-122"/>
-                <a:cs typeface="Segoe UI" pitchFamily="34" charset="-120"/>
-              </a:rPr>
-              <a:t>Air, ground and sea: every scaled platform adds range, EW exposure and nodes to a network.</a:t>
             </a:r>
             <a:endParaRPr lang="en-US" sz="1200" dirty="0"/>
           </a:p>
@@ -5487,7 +6953,7 @@
                 <a:ea typeface="Segoe UI" pitchFamily="34" charset="-122"/>
                 <a:cs typeface="Segoe UI" pitchFamily="34" charset="-120"/>
               </a:rPr>
-              <a:t>Growth comes from new volume — strike, interceptors, UGVs — where the radio socket is least likely to be locked.</a:t>
+              <a:t>Most of the growth is strike, interceptors and UGVs.</a:t>
             </a:r>
             <a:endParaRPr lang="en-US" sz="1200" dirty="0"/>
           </a:p>
@@ -5996,7 +7462,7 @@
                 <a:ea typeface="Segoe UI" pitchFamily="34" charset="-122"/>
                 <a:cs typeface="Segoe UI" pitchFamily="34" charset="-120"/>
               </a:rPr>
-              <a:t>Rests on contracts I can see — the design window is now</a:t>
+              <a:t>Rests on contracts visible today</a:t>
             </a:r>
             <a:endParaRPr lang="en-US" sz="1100" dirty="0"/>
           </a:p>
@@ -6234,46 +7700,7 @@
       </p:sp>
       <p:sp>
         <p:nvSpPr>
-          <p:cNvPr id="4" name="Text 2"/>
-          <p:cNvSpPr txBox="1"/>
-          <p:nvPr/>
-        </p:nvSpPr>
-        <p:spPr>
-          <a:xfrm>
-            <a:off x="640080" y="4590288"/>
-            <a:ext cx="7863840" cy="256032"/>
-          </a:xfrm>
-          <a:prstGeom prst="rect">
-            <a:avLst/>
-          </a:prstGeom>
-          <a:noFill/>
-          <a:ln/>
-        </p:spPr>
-        <p:txBody>
-          <a:bodyPr wrap="square" lIns="0" tIns="0" rIns="0" bIns="0" rtlCol="0" anchor="ctr"/>
-          <a:lstStyle/>
-          <a:p>
-            <a:pPr indent="0" marL="0">
-              <a:buNone/>
-            </a:pPr>
-            <a:r>
-              <a:rPr lang="en-US" sz="950" dirty="0">
-                <a:solidFill>
-                  <a:srgbClr val="F05A55"/>
-                </a:solidFill>
-                <a:latin typeface="Segoe UI" pitchFamily="34" charset="0"/>
-                <a:ea typeface="Segoe UI" pitchFamily="34" charset="-122"/>
-                <a:cs typeface="Segoe UI" pitchFamily="34" charset="-120"/>
-              </a:rPr>
-              <a:t>"We are not European. We are independent." — the pitch Doodle can make and defend.</a:t>
-            </a:r>
-            <a:endParaRPr lang="en-US" sz="950" dirty="0"/>
-          </a:p>
-        </p:txBody>
-      </p:sp>
-      <p:sp>
-        <p:nvSpPr>
-          <p:cNvPr id="5" name="Shape 3"/>
+          <p:cNvPr id="4" name="Shape 2"/>
           <p:cNvSpPr/>
           <p:nvPr/>
         </p:nvSpPr>
@@ -6298,7 +7725,7 @@
       </p:sp>
       <p:sp>
         <p:nvSpPr>
-          <p:cNvPr id="6" name="Shape 4"/>
+          <p:cNvPr id="5" name="Shape 3"/>
           <p:cNvSpPr/>
           <p:nvPr/>
         </p:nvSpPr>
@@ -6323,7 +7750,7 @@
       </p:sp>
       <p:sp>
         <p:nvSpPr>
-          <p:cNvPr id="7" name="Text 5"/>
+          <p:cNvPr id="6" name="Text 4"/>
           <p:cNvSpPr txBox="1"/>
           <p:nvPr/>
         </p:nvSpPr>
@@ -6362,7 +7789,7 @@
       </p:sp>
       <p:sp>
         <p:nvSpPr>
-          <p:cNvPr id="8" name="Text 6"/>
+          <p:cNvPr id="7" name="Text 5"/>
           <p:cNvSpPr txBox="1"/>
           <p:nvPr/>
         </p:nvSpPr>
@@ -6401,7 +7828,7 @@
       </p:sp>
       <p:sp>
         <p:nvSpPr>
-          <p:cNvPr id="9" name="Text 7"/>
+          <p:cNvPr id="8" name="Text 6"/>
           <p:cNvSpPr txBox="1"/>
           <p:nvPr/>
         </p:nvSpPr>
@@ -6486,7 +7913,7 @@
       </p:sp>
       <p:sp>
         <p:nvSpPr>
-          <p:cNvPr id="10" name="Text 8"/>
+          <p:cNvPr id="9" name="Text 7"/>
           <p:cNvSpPr txBox="1"/>
           <p:nvPr/>
         </p:nvSpPr>
@@ -6563,7 +7990,7 @@
                 <a:ea typeface="Segoe UI" pitchFamily="34" charset="-122"/>
                 <a:cs typeface="Segoe UI" pitchFamily="34" charset="-120"/>
               </a:rPr>
-              <a:t>European sovereignty — we can't sell a flag</a:t>
+              <a:t>A sovereignty pitch — Doodle is a US company</a:t>
             </a:r>
             <a:endParaRPr lang="en-US" sz="1250" dirty="0"/>
           </a:p>
@@ -7261,45 +8688,6 @@
           </a:p>
         </p:txBody>
       </p:sp>
-      <p:sp>
-        <p:nvSpPr>
-          <p:cNvPr id="20" name="Text 18"/>
-          <p:cNvSpPr txBox="1"/>
-          <p:nvPr/>
-        </p:nvSpPr>
-        <p:spPr>
-          <a:xfrm>
-            <a:off x="640080" y="3931920"/>
-            <a:ext cx="7863840" cy="457200"/>
-          </a:xfrm>
-          <a:prstGeom prst="rect">
-            <a:avLst/>
-          </a:prstGeom>
-          <a:noFill/>
-          <a:ln/>
-        </p:spPr>
-        <p:txBody>
-          <a:bodyPr wrap="square" lIns="0" tIns="0" rIns="0" bIns="0" rtlCol="0" anchor="ctr"/>
-          <a:lstStyle/>
-          <a:p>
-            <a:pPr indent="0" marL="0">
-              <a:buNone/>
-            </a:pPr>
-            <a:r>
-              <a:rPr lang="en-US" sz="1150" i="1" dirty="0">
-                <a:solidFill>
-                  <a:srgbClr val="8E98A3"/>
-                </a:solidFill>
-                <a:latin typeface="Segoe UI" pitchFamily="34" charset="0"/>
-                <a:ea typeface="Segoe UI" pitchFamily="34" charset="-122"/>
-                <a:cs typeface="Segoe UI" pitchFamily="34" charset="-120"/>
-              </a:rPr>
-              <a:t>Proof = an eval kit in an engineer's hands and a number he measured. Credibility = a local reference who already holds the relationship.</a:t>
-            </a:r>
-            <a:endParaRPr lang="en-US" sz="1150" dirty="0"/>
-          </a:p>
-        </p:txBody>
-      </p:sp>
     </p:spTree>
   </p:cSld>
   <p:clrMapOvr>
@@ -7443,7 +8831,7 @@
                 <a:ea typeface="Segoe UI" pitchFamily="34" charset="-122"/>
                 <a:cs typeface="Segoe UI" pitchFamily="34" charset="-120"/>
               </a:rPr>
-              <a:t>One design authority, one owner. Factories and regional support share the credit.</a:t>
+              <a:t>One design authority, one owner.</a:t>
             </a:r>
             <a:endParaRPr lang="en-US" sz="950" dirty="0"/>
           </a:p>
@@ -8004,45 +9392,6 @@
               <a:t>of evidenced value sits in German programmes; ~17% in French.</a:t>
             </a:r>
             <a:endParaRPr lang="en-US" sz="1200" dirty="0"/>
-          </a:p>
-        </p:txBody>
-      </p:sp>
-      <p:sp>
-        <p:nvSpPr>
-          <p:cNvPr id="19" name="Text 17"/>
-          <p:cNvSpPr txBox="1"/>
-          <p:nvPr/>
-        </p:nvSpPr>
-        <p:spPr>
-          <a:xfrm>
-            <a:off x="6172200" y="2926080"/>
-            <a:ext cx="2331720" cy="1188720"/>
-          </a:xfrm>
-          <a:prstGeom prst="rect">
-            <a:avLst/>
-          </a:prstGeom>
-          <a:noFill/>
-          <a:ln/>
-        </p:spPr>
-        <p:txBody>
-          <a:bodyPr wrap="square" lIns="0" tIns="0" rIns="0" bIns="0" rtlCol="0" anchor="t"/>
-          <a:lstStyle/>
-          <a:p>
-            <a:pPr indent="0" marL="0">
-              <a:buNone/>
-            </a:pPr>
-            <a:r>
-              <a:rPr lang="en-US" sz="1150" dirty="0">
-                <a:solidFill>
-                  <a:srgbClr val="C9CED4"/>
-                </a:solidFill>
-                <a:latin typeface="Segoe UI" pitchFamily="34" charset="0"/>
-                <a:ea typeface="Segoe UI" pitchFamily="34" charset="-122"/>
-                <a:cs typeface="Segoe UI" pitchFamily="34" charset="-120"/>
-              </a:rPr>
-              <a:t>The radio decision sits with the design authority — which doesn't always match where a platform is built.</a:t>
-            </a:r>
-            <a:endParaRPr lang="en-US" sz="1150" dirty="0"/>
           </a:p>
         </p:txBody>
       </p:sp>

</xml_diff>